<commit_message>
Compare company pricing with market averages across the reporting demo
</commit_message>
<xml_diff>
--- a/reports/Country-Product-Report.pptx
+++ b/reports/Country-Product-Report.pptx
@@ -2,24 +2,24 @@
 <file path=ppt/presentation.xml><?xml version="1.0" encoding="utf-8"?>
 <p:presentation xmlns:p="http://schemas.openxmlformats.org/presentationml/2006/main">
   <p:sldMasterIdLst>
-    <p:sldMasterId xmlns:r="http://schemas.openxmlformats.org/officeDocument/2006/relationships" id="2147483648" r:id="R670872658e6048d9"/>
+    <p:sldMasterId xmlns:r="http://schemas.openxmlformats.org/officeDocument/2006/relationships" id="2147483648" r:id="Rff4a0e5ed9ed49e5"/>
   </p:sldMasterIdLst>
   <p:notesMasterIdLst>
-    <p:notesMasterId xmlns:r="http://schemas.openxmlformats.org/officeDocument/2006/relationships" r:id="Re491665ac5664513"/>
+    <p:notesMasterId xmlns:r="http://schemas.openxmlformats.org/officeDocument/2006/relationships" r:id="Rde84073506554126"/>
   </p:notesMasterIdLst>
   <p:sldIdLst>
-    <p:sldId xmlns:r="http://schemas.openxmlformats.org/officeDocument/2006/relationships" id="256" r:id="R4f2443da49a94e66"/>
-    <p:sldId xmlns:r="http://schemas.openxmlformats.org/officeDocument/2006/relationships" id="257" r:id="Re2b866f968774130"/>
-    <p:sldId xmlns:r="http://schemas.openxmlformats.org/officeDocument/2006/relationships" id="258" r:id="R8d2ceeb4667241a3"/>
-    <p:sldId xmlns:r="http://schemas.openxmlformats.org/officeDocument/2006/relationships" id="259" r:id="R6de048d6e0194cfd"/>
-    <p:sldId xmlns:r="http://schemas.openxmlformats.org/officeDocument/2006/relationships" id="260" r:id="R66ff009401cb45ec"/>
-    <p:sldId xmlns:r="http://schemas.openxmlformats.org/officeDocument/2006/relationships" id="261" r:id="R5ced246b69264475"/>
-    <p:sldId xmlns:r="http://schemas.openxmlformats.org/officeDocument/2006/relationships" id="262" r:id="Rbffdb682333a4b95"/>
-    <p:sldId xmlns:r="http://schemas.openxmlformats.org/officeDocument/2006/relationships" id="263" r:id="R48a1c6bee7134eb9"/>
-    <p:sldId xmlns:r="http://schemas.openxmlformats.org/officeDocument/2006/relationships" id="264" r:id="Rbfc1200931d34df7"/>
-    <p:sldId xmlns:r="http://schemas.openxmlformats.org/officeDocument/2006/relationships" id="265" r:id="R670013f8a7084680"/>
-    <p:sldId xmlns:r="http://schemas.openxmlformats.org/officeDocument/2006/relationships" id="266" r:id="R914a3f29b7dc465b"/>
-    <p:sldId xmlns:r="http://schemas.openxmlformats.org/officeDocument/2006/relationships" id="267" r:id="R0346709240794e0d"/>
+    <p:sldId xmlns:r="http://schemas.openxmlformats.org/officeDocument/2006/relationships" id="256" r:id="R63f1e92ef2624175"/>
+    <p:sldId xmlns:r="http://schemas.openxmlformats.org/officeDocument/2006/relationships" id="257" r:id="R5e17a7b32a2b40f5"/>
+    <p:sldId xmlns:r="http://schemas.openxmlformats.org/officeDocument/2006/relationships" id="258" r:id="Ra0625bd090db42c6"/>
+    <p:sldId xmlns:r="http://schemas.openxmlformats.org/officeDocument/2006/relationships" id="259" r:id="Rfbe55a05c0d64e49"/>
+    <p:sldId xmlns:r="http://schemas.openxmlformats.org/officeDocument/2006/relationships" id="260" r:id="Ra3358d41533b4d2e"/>
+    <p:sldId xmlns:r="http://schemas.openxmlformats.org/officeDocument/2006/relationships" id="261" r:id="R2d551bc356814a8b"/>
+    <p:sldId xmlns:r="http://schemas.openxmlformats.org/officeDocument/2006/relationships" id="262" r:id="R90deec21c8a54916"/>
+    <p:sldId xmlns:r="http://schemas.openxmlformats.org/officeDocument/2006/relationships" id="263" r:id="Re3d64d89c57e4d35"/>
+    <p:sldId xmlns:r="http://schemas.openxmlformats.org/officeDocument/2006/relationships" id="264" r:id="R629ed5e4ae0043ee"/>
+    <p:sldId xmlns:r="http://schemas.openxmlformats.org/officeDocument/2006/relationships" id="265" r:id="R5c91023e5c0f416e"/>
+    <p:sldId xmlns:r="http://schemas.openxmlformats.org/officeDocument/2006/relationships" id="266" r:id="Rd50776682db142b6"/>
+    <p:sldId xmlns:r="http://schemas.openxmlformats.org/officeDocument/2006/relationships" id="267" r:id="R3a9273c9ee5d4962"/>
   </p:sldIdLst>
   <p:sldSz cx="12192000" cy="6858000"/>
   <p:notesSz cx="6858000" cy="9144000"/>
@@ -1291,7 +1291,7 @@
   </p:cSld>
   <p:clrMap bg1="lt1" tx1="dk1" bg2="lt2" tx2="dk2" accent1="accent1" accent2="accent2" accent3="accent3" accent4="accent4" accent5="accent5" accent6="accent6" hlink="hlink" folHlink="folHlink"/>
   <p:sldLayoutIdLst>
-    <p:sldLayoutId xmlns:r="http://schemas.openxmlformats.org/officeDocument/2006/relationships" id="2147483649" r:id="R3cabe9c6977746ea"/>
+    <p:sldLayoutId xmlns:r="http://schemas.openxmlformats.org/officeDocument/2006/relationships" id="2147483649" r:id="R60152af4051048f0"/>
   </p:sldLayoutIdLst>
   <p:txStyles>
     <p:titleStyle>
@@ -2008,7 +2008,7 @@
           <c:idx val="0"/>
           <c:order val="0"/>
           <c:tx>
-            <c:v>ASP</c:v>
+            <c:v>Company</c:v>
           </c:tx>
           <c:spPr>
             <a:solidFill xmlns:a="http://schemas.openxmlformats.org/drawingml/2006/main">
@@ -2060,6 +2060,69 @@
                 </c:pt>
                 <c:pt idx="3">
                   <c:v>484</c:v>
+                </c:pt>
+              </c:numCache>
+            </c:numRef>
+          </c:val>
+          <c:smooth val="0"/>
+        </c:ser>
+        <c:ser>
+          <c:idx val="1"/>
+          <c:order val="1"/>
+          <c:tx>
+            <c:v>Market average</c:v>
+          </c:tx>
+          <c:spPr>
+            <a:solidFill xmlns:a="http://schemas.openxmlformats.org/drawingml/2006/main">
+              <a:srgbClr val="A85D24"/>
+            </a:solidFill>
+            <a:ln xmlns:a="http://schemas.openxmlformats.org/drawingml/2006/main" w="28575">
+              <a:solidFill>
+                <a:srgbClr val="A85D24"/>
+              </a:solidFill>
+              <a:prstDash val="dash"/>
+            </a:ln>
+          </c:spPr>
+          <c:marker>
+            <c:symbol val="none"/>
+          </c:marker>
+          <c:cat>
+            <c:strRef>
+              <c:f>'Chart Data'!$C$2:$C$5</c:f>
+              <c:strCache>
+                <c:ptCount val="4"/>
+                <c:pt idx="0">
+                  <c:v>Q1</c:v>
+                </c:pt>
+                <c:pt idx="1">
+                  <c:v>Q2</c:v>
+                </c:pt>
+                <c:pt idx="2">
+                  <c:v>Q3</c:v>
+                </c:pt>
+                <c:pt idx="3">
+                  <c:v>Q4</c:v>
+                </c:pt>
+              </c:strCache>
+            </c:strRef>
+          </c:cat>
+          <c:val>
+            <c:numRef>
+              <c:f>'Chart Data'!$D$2:$D$5</c:f>
+              <c:numCache>
+                <c:formatCode>0</c:formatCode>
+                <c:ptCount val="4"/>
+                <c:pt idx="0">
+                  <c:v>425</c:v>
+                </c:pt>
+                <c:pt idx="1">
+                  <c:v>420</c:v>
+                </c:pt>
+                <c:pt idx="2">
+                  <c:v>415</c:v>
+                </c:pt>
+                <c:pt idx="3">
+                  <c:v>410</c:v>
                 </c:pt>
               </c:numCache>
             </c:numRef>
@@ -2166,6 +2229,23 @@
         <c:crossBetween val="between"/>
       </c:valAx>
     </c:plotArea>
+    <c:legend>
+      <c:legendPos val="b"/>
+      <c:overlay val="0"/>
+      <c:txPr>
+        <a:bodyPr xmlns:a="http://schemas.openxmlformats.org/drawingml/2006/main" anchorCtr="1"/>
+        <a:lstStyle xmlns:a="http://schemas.openxmlformats.org/drawingml/2006/main"/>
+        <a:p xmlns:a="http://schemas.openxmlformats.org/drawingml/2006/main">
+          <a:pPr>
+            <a:defRPr sz="1275">
+              <a:latin typeface="Arial"/>
+              <a:ea typeface="Arial"/>
+              <a:cs typeface="Arial"/>
+            </a:defRPr>
+          </a:pPr>
+        </a:p>
+      </c:txPr>
+    </c:legend>
     <c:plotVisOnly val="1"/>
   </c:chart>
   <c:externalData r:id="rIdChartSnapshot1">
@@ -2364,7 +2444,7 @@
           <c:idx val="0"/>
           <c:order val="0"/>
           <c:tx>
-            <c:v>ASP</c:v>
+            <c:v>Company</c:v>
           </c:tx>
           <c:spPr>
             <a:solidFill xmlns:a="http://schemas.openxmlformats.org/drawingml/2006/main">
@@ -2416,6 +2496,69 @@
                 </c:pt>
                 <c:pt idx="3">
                   <c:v>569</c:v>
+                </c:pt>
+              </c:numCache>
+            </c:numRef>
+          </c:val>
+          <c:smooth val="0"/>
+        </c:ser>
+        <c:ser>
+          <c:idx val="1"/>
+          <c:order val="1"/>
+          <c:tx>
+            <c:v>Market average</c:v>
+          </c:tx>
+          <c:spPr>
+            <a:solidFill xmlns:a="http://schemas.openxmlformats.org/drawingml/2006/main">
+              <a:srgbClr val="A85D24"/>
+            </a:solidFill>
+            <a:ln xmlns:a="http://schemas.openxmlformats.org/drawingml/2006/main" w="28575">
+              <a:solidFill>
+                <a:srgbClr val="A85D24"/>
+              </a:solidFill>
+              <a:prstDash val="dash"/>
+            </a:ln>
+          </c:spPr>
+          <c:marker>
+            <c:symbol val="none"/>
+          </c:marker>
+          <c:cat>
+            <c:strRef>
+              <c:f>'Chart Data'!$C$2:$C$5</c:f>
+              <c:strCache>
+                <c:ptCount val="4"/>
+                <c:pt idx="0">
+                  <c:v>Q1</c:v>
+                </c:pt>
+                <c:pt idx="1">
+                  <c:v>Q2</c:v>
+                </c:pt>
+                <c:pt idx="2">
+                  <c:v>Q3</c:v>
+                </c:pt>
+                <c:pt idx="3">
+                  <c:v>Q4</c:v>
+                </c:pt>
+              </c:strCache>
+            </c:strRef>
+          </c:cat>
+          <c:val>
+            <c:numRef>
+              <c:f>'Chart Data'!$D$2:$D$5</c:f>
+              <c:numCache>
+                <c:formatCode>0</c:formatCode>
+                <c:ptCount val="4"/>
+                <c:pt idx="0">
+                  <c:v>510</c:v>
+                </c:pt>
+                <c:pt idx="1">
+                  <c:v>505</c:v>
+                </c:pt>
+                <c:pt idx="2">
+                  <c:v>500</c:v>
+                </c:pt>
+                <c:pt idx="3">
+                  <c:v>495</c:v>
                 </c:pt>
               </c:numCache>
             </c:numRef>
@@ -2522,6 +2665,23 @@
         <c:crossBetween val="between"/>
       </c:valAx>
     </c:plotArea>
+    <c:legend>
+      <c:legendPos val="b"/>
+      <c:overlay val="0"/>
+      <c:txPr>
+        <a:bodyPr xmlns:a="http://schemas.openxmlformats.org/drawingml/2006/main" anchorCtr="1"/>
+        <a:lstStyle xmlns:a="http://schemas.openxmlformats.org/drawingml/2006/main"/>
+        <a:p xmlns:a="http://schemas.openxmlformats.org/drawingml/2006/main">
+          <a:pPr>
+            <a:defRPr sz="1275">
+              <a:latin typeface="Arial"/>
+              <a:ea typeface="Arial"/>
+              <a:cs typeface="Arial"/>
+            </a:defRPr>
+          </a:pPr>
+        </a:p>
+      </c:txPr>
+    </c:legend>
     <c:plotVisOnly val="1"/>
   </c:chart>
   <c:externalData r:id="rIdChartSnapshot1">
@@ -2720,7 +2880,7 @@
           <c:idx val="0"/>
           <c:order val="0"/>
           <c:tx>
-            <c:v>ASP</c:v>
+            <c:v>Company</c:v>
           </c:tx>
           <c:spPr>
             <a:solidFill xmlns:a="http://schemas.openxmlformats.org/drawingml/2006/main">
@@ -2772,6 +2932,69 @@
                 </c:pt>
                 <c:pt idx="3">
                   <c:v>644</c:v>
+                </c:pt>
+              </c:numCache>
+            </c:numRef>
+          </c:val>
+          <c:smooth val="0"/>
+        </c:ser>
+        <c:ser>
+          <c:idx val="1"/>
+          <c:order val="1"/>
+          <c:tx>
+            <c:v>Market average</c:v>
+          </c:tx>
+          <c:spPr>
+            <a:solidFill xmlns:a="http://schemas.openxmlformats.org/drawingml/2006/main">
+              <a:srgbClr val="A85D24"/>
+            </a:solidFill>
+            <a:ln xmlns:a="http://schemas.openxmlformats.org/drawingml/2006/main" w="28575">
+              <a:solidFill>
+                <a:srgbClr val="A85D24"/>
+              </a:solidFill>
+              <a:prstDash val="dash"/>
+            </a:ln>
+          </c:spPr>
+          <c:marker>
+            <c:symbol val="none"/>
+          </c:marker>
+          <c:cat>
+            <c:strRef>
+              <c:f>'Chart Data'!$C$2:$C$5</c:f>
+              <c:strCache>
+                <c:ptCount val="4"/>
+                <c:pt idx="0">
+                  <c:v>Q1</c:v>
+                </c:pt>
+                <c:pt idx="1">
+                  <c:v>Q2</c:v>
+                </c:pt>
+                <c:pt idx="2">
+                  <c:v>Q3</c:v>
+                </c:pt>
+                <c:pt idx="3">
+                  <c:v>Q4</c:v>
+                </c:pt>
+              </c:strCache>
+            </c:strRef>
+          </c:cat>
+          <c:val>
+            <c:numRef>
+              <c:f>'Chart Data'!$D$2:$D$5</c:f>
+              <c:numCache>
+                <c:formatCode>0</c:formatCode>
+                <c:ptCount val="4"/>
+                <c:pt idx="0">
+                  <c:v>585</c:v>
+                </c:pt>
+                <c:pt idx="1">
+                  <c:v>580</c:v>
+                </c:pt>
+                <c:pt idx="2">
+                  <c:v>575</c:v>
+                </c:pt>
+                <c:pt idx="3">
+                  <c:v>570</c:v>
                 </c:pt>
               </c:numCache>
             </c:numRef>
@@ -2878,6 +3101,23 @@
         <c:crossBetween val="between"/>
       </c:valAx>
     </c:plotArea>
+    <c:legend>
+      <c:legendPos val="b"/>
+      <c:overlay val="0"/>
+      <c:txPr>
+        <a:bodyPr xmlns:a="http://schemas.openxmlformats.org/drawingml/2006/main" anchorCtr="1"/>
+        <a:lstStyle xmlns:a="http://schemas.openxmlformats.org/drawingml/2006/main"/>
+        <a:p xmlns:a="http://schemas.openxmlformats.org/drawingml/2006/main">
+          <a:pPr>
+            <a:defRPr sz="1275">
+              <a:latin typeface="Arial"/>
+              <a:ea typeface="Arial"/>
+              <a:cs typeface="Arial"/>
+            </a:defRPr>
+          </a:pPr>
+        </a:p>
+      </c:txPr>
+    </c:legend>
     <c:plotVisOnly val="1"/>
   </c:chart>
   <c:externalData r:id="rIdChartSnapshot1">
@@ -3076,7 +3316,7 @@
           <c:idx val="0"/>
           <c:order val="0"/>
           <c:tx>
-            <c:v>ASP</c:v>
+            <c:v>Company</c:v>
           </c:tx>
           <c:spPr>
             <a:solidFill xmlns:a="http://schemas.openxmlformats.org/drawingml/2006/main">
@@ -3128,6 +3368,69 @@
                 </c:pt>
                 <c:pt idx="3">
                   <c:v>729</c:v>
+                </c:pt>
+              </c:numCache>
+            </c:numRef>
+          </c:val>
+          <c:smooth val="0"/>
+        </c:ser>
+        <c:ser>
+          <c:idx val="1"/>
+          <c:order val="1"/>
+          <c:tx>
+            <c:v>Market average</c:v>
+          </c:tx>
+          <c:spPr>
+            <a:solidFill xmlns:a="http://schemas.openxmlformats.org/drawingml/2006/main">
+              <a:srgbClr val="A85D24"/>
+            </a:solidFill>
+            <a:ln xmlns:a="http://schemas.openxmlformats.org/drawingml/2006/main" w="28575">
+              <a:solidFill>
+                <a:srgbClr val="A85D24"/>
+              </a:solidFill>
+              <a:prstDash val="dash"/>
+            </a:ln>
+          </c:spPr>
+          <c:marker>
+            <c:symbol val="none"/>
+          </c:marker>
+          <c:cat>
+            <c:strRef>
+              <c:f>'Chart Data'!$C$2:$C$5</c:f>
+              <c:strCache>
+                <c:ptCount val="4"/>
+                <c:pt idx="0">
+                  <c:v>Q1</c:v>
+                </c:pt>
+                <c:pt idx="1">
+                  <c:v>Q2</c:v>
+                </c:pt>
+                <c:pt idx="2">
+                  <c:v>Q3</c:v>
+                </c:pt>
+                <c:pt idx="3">
+                  <c:v>Q4</c:v>
+                </c:pt>
+              </c:strCache>
+            </c:strRef>
+          </c:cat>
+          <c:val>
+            <c:numRef>
+              <c:f>'Chart Data'!$D$2:$D$5</c:f>
+              <c:numCache>
+                <c:formatCode>0</c:formatCode>
+                <c:ptCount val="4"/>
+                <c:pt idx="0">
+                  <c:v>670</c:v>
+                </c:pt>
+                <c:pt idx="1">
+                  <c:v>665</c:v>
+                </c:pt>
+                <c:pt idx="2">
+                  <c:v>660</c:v>
+                </c:pt>
+                <c:pt idx="3">
+                  <c:v>655</c:v>
                 </c:pt>
               </c:numCache>
             </c:numRef>
@@ -3234,6 +3537,23 @@
         <c:crossBetween val="between"/>
       </c:valAx>
     </c:plotArea>
+    <c:legend>
+      <c:legendPos val="b"/>
+      <c:overlay val="0"/>
+      <c:txPr>
+        <a:bodyPr xmlns:a="http://schemas.openxmlformats.org/drawingml/2006/main" anchorCtr="1"/>
+        <a:lstStyle xmlns:a="http://schemas.openxmlformats.org/drawingml/2006/main"/>
+        <a:p xmlns:a="http://schemas.openxmlformats.org/drawingml/2006/main">
+          <a:pPr>
+            <a:defRPr sz="1275">
+              <a:latin typeface="Arial"/>
+              <a:ea typeface="Arial"/>
+              <a:cs typeface="Arial"/>
+            </a:defRPr>
+          </a:pPr>
+        </a:p>
+      </c:txPr>
+    </c:legend>
     <c:plotVisOnly val="1"/>
   </c:chart>
   <c:externalData r:id="rIdChartSnapshot1">
@@ -3432,7 +3752,7 @@
           <c:idx val="0"/>
           <c:order val="0"/>
           <c:tx>
-            <c:v>ASP</c:v>
+            <c:v>Company</c:v>
           </c:tx>
           <c:spPr>
             <a:solidFill xmlns:a="http://schemas.openxmlformats.org/drawingml/2006/main">
@@ -3484,6 +3804,69 @@
                 </c:pt>
                 <c:pt idx="3">
                   <c:v>452</c:v>
+                </c:pt>
+              </c:numCache>
+            </c:numRef>
+          </c:val>
+          <c:smooth val="0"/>
+        </c:ser>
+        <c:ser>
+          <c:idx val="1"/>
+          <c:order val="1"/>
+          <c:tx>
+            <c:v>Market average</c:v>
+          </c:tx>
+          <c:spPr>
+            <a:solidFill xmlns:a="http://schemas.openxmlformats.org/drawingml/2006/main">
+              <a:srgbClr val="A85D24"/>
+            </a:solidFill>
+            <a:ln xmlns:a="http://schemas.openxmlformats.org/drawingml/2006/main" w="28575">
+              <a:solidFill>
+                <a:srgbClr val="A85D24"/>
+              </a:solidFill>
+              <a:prstDash val="dash"/>
+            </a:ln>
+          </c:spPr>
+          <c:marker>
+            <c:symbol val="none"/>
+          </c:marker>
+          <c:cat>
+            <c:strRef>
+              <c:f>'Chart Data'!$C$2:$C$5</c:f>
+              <c:strCache>
+                <c:ptCount val="4"/>
+                <c:pt idx="0">
+                  <c:v>Q1</c:v>
+                </c:pt>
+                <c:pt idx="1">
+                  <c:v>Q2</c:v>
+                </c:pt>
+                <c:pt idx="2">
+                  <c:v>Q3</c:v>
+                </c:pt>
+                <c:pt idx="3">
+                  <c:v>Q4</c:v>
+                </c:pt>
+              </c:strCache>
+            </c:strRef>
+          </c:cat>
+          <c:val>
+            <c:numRef>
+              <c:f>'Chart Data'!$D$2:$D$5</c:f>
+              <c:numCache>
+                <c:formatCode>0</c:formatCode>
+                <c:ptCount val="4"/>
+                <c:pt idx="0">
+                  <c:v>405</c:v>
+                </c:pt>
+                <c:pt idx="1">
+                  <c:v>398</c:v>
+                </c:pt>
+                <c:pt idx="2">
+                  <c:v>391</c:v>
+                </c:pt>
+                <c:pt idx="3">
+                  <c:v>384</c:v>
                 </c:pt>
               </c:numCache>
             </c:numRef>
@@ -3590,6 +3973,23 @@
         <c:crossBetween val="between"/>
       </c:valAx>
     </c:plotArea>
+    <c:legend>
+      <c:legendPos val="b"/>
+      <c:overlay val="0"/>
+      <c:txPr>
+        <a:bodyPr xmlns:a="http://schemas.openxmlformats.org/drawingml/2006/main" anchorCtr="1"/>
+        <a:lstStyle xmlns:a="http://schemas.openxmlformats.org/drawingml/2006/main"/>
+        <a:p xmlns:a="http://schemas.openxmlformats.org/drawingml/2006/main">
+          <a:pPr>
+            <a:defRPr sz="1275">
+              <a:latin typeface="Arial"/>
+              <a:ea typeface="Arial"/>
+              <a:cs typeface="Arial"/>
+            </a:defRPr>
+          </a:pPr>
+        </a:p>
+      </c:txPr>
+    </c:legend>
     <c:plotVisOnly val="1"/>
   </c:chart>
   <c:externalData r:id="rIdChartSnapshot1">
@@ -3788,7 +4188,7 @@
           <c:idx val="0"/>
           <c:order val="0"/>
           <c:tx>
-            <c:v>ASP</c:v>
+            <c:v>Company</c:v>
           </c:tx>
           <c:spPr>
             <a:solidFill xmlns:a="http://schemas.openxmlformats.org/drawingml/2006/main">
@@ -3840,6 +4240,69 @@
                 </c:pt>
                 <c:pt idx="3">
                   <c:v>516</c:v>
+                </c:pt>
+              </c:numCache>
+            </c:numRef>
+          </c:val>
+          <c:smooth val="0"/>
+        </c:ser>
+        <c:ser>
+          <c:idx val="1"/>
+          <c:order val="1"/>
+          <c:tx>
+            <c:v>Market average</c:v>
+          </c:tx>
+          <c:spPr>
+            <a:solidFill xmlns:a="http://schemas.openxmlformats.org/drawingml/2006/main">
+              <a:srgbClr val="A85D24"/>
+            </a:solidFill>
+            <a:ln xmlns:a="http://schemas.openxmlformats.org/drawingml/2006/main" w="28575">
+              <a:solidFill>
+                <a:srgbClr val="A85D24"/>
+              </a:solidFill>
+              <a:prstDash val="dash"/>
+            </a:ln>
+          </c:spPr>
+          <c:marker>
+            <c:symbol val="none"/>
+          </c:marker>
+          <c:cat>
+            <c:strRef>
+              <c:f>'Chart Data'!$C$2:$C$5</c:f>
+              <c:strCache>
+                <c:ptCount val="4"/>
+                <c:pt idx="0">
+                  <c:v>Q1</c:v>
+                </c:pt>
+                <c:pt idx="1">
+                  <c:v>Q2</c:v>
+                </c:pt>
+                <c:pt idx="2">
+                  <c:v>Q3</c:v>
+                </c:pt>
+                <c:pt idx="3">
+                  <c:v>Q4</c:v>
+                </c:pt>
+              </c:strCache>
+            </c:strRef>
+          </c:cat>
+          <c:val>
+            <c:numRef>
+              <c:f>'Chart Data'!$D$2:$D$5</c:f>
+              <c:numCache>
+                <c:formatCode>0</c:formatCode>
+                <c:ptCount val="4"/>
+                <c:pt idx="0">
+                  <c:v>445</c:v>
+                </c:pt>
+                <c:pt idx="1">
+                  <c:v>442</c:v>
+                </c:pt>
+                <c:pt idx="2">
+                  <c:v>439</c:v>
+                </c:pt>
+                <c:pt idx="3">
+                  <c:v>436</c:v>
                 </c:pt>
               </c:numCache>
             </c:numRef>
@@ -3946,6 +4409,23 @@
         <c:crossBetween val="between"/>
       </c:valAx>
     </c:plotArea>
+    <c:legend>
+      <c:legendPos val="b"/>
+      <c:overlay val="0"/>
+      <c:txPr>
+        <a:bodyPr xmlns:a="http://schemas.openxmlformats.org/drawingml/2006/main" anchorCtr="1"/>
+        <a:lstStyle xmlns:a="http://schemas.openxmlformats.org/drawingml/2006/main"/>
+        <a:p xmlns:a="http://schemas.openxmlformats.org/drawingml/2006/main">
+          <a:pPr>
+            <a:defRPr sz="1275">
+              <a:latin typeface="Arial"/>
+              <a:ea typeface="Arial"/>
+              <a:cs typeface="Arial"/>
+            </a:defRPr>
+          </a:pPr>
+        </a:p>
+      </c:txPr>
+    </c:legend>
     <c:plotVisOnly val="1"/>
   </c:chart>
   <c:externalData r:id="rIdChartSnapshot1">
@@ -3966,7 +4446,7 @@
           <c:idx val="0"/>
           <c:order val="0"/>
           <c:tx>
-            <c:v>ASP</c:v>
+            <c:v>Company</c:v>
           </c:tx>
           <c:spPr>
             <a:solidFill xmlns:a="http://schemas.openxmlformats.org/drawingml/2006/main">
@@ -4018,6 +4498,69 @@
                 </c:pt>
                 <c:pt idx="3">
                   <c:v>537</c:v>
+                </c:pt>
+              </c:numCache>
+            </c:numRef>
+          </c:val>
+          <c:smooth val="0"/>
+        </c:ser>
+        <c:ser>
+          <c:idx val="1"/>
+          <c:order val="1"/>
+          <c:tx>
+            <c:v>Market average</c:v>
+          </c:tx>
+          <c:spPr>
+            <a:solidFill xmlns:a="http://schemas.openxmlformats.org/drawingml/2006/main">
+              <a:srgbClr val="A85D24"/>
+            </a:solidFill>
+            <a:ln xmlns:a="http://schemas.openxmlformats.org/drawingml/2006/main" w="28575">
+              <a:solidFill>
+                <a:srgbClr val="A85D24"/>
+              </a:solidFill>
+              <a:prstDash val="dash"/>
+            </a:ln>
+          </c:spPr>
+          <c:marker>
+            <c:symbol val="none"/>
+          </c:marker>
+          <c:cat>
+            <c:strRef>
+              <c:f>'Chart Data'!$C$2:$C$5</c:f>
+              <c:strCache>
+                <c:ptCount val="4"/>
+                <c:pt idx="0">
+                  <c:v>Q1</c:v>
+                </c:pt>
+                <c:pt idx="1">
+                  <c:v>Q2</c:v>
+                </c:pt>
+                <c:pt idx="2">
+                  <c:v>Q3</c:v>
+                </c:pt>
+                <c:pt idx="3">
+                  <c:v>Q4</c:v>
+                </c:pt>
+              </c:strCache>
+            </c:strRef>
+          </c:cat>
+          <c:val>
+            <c:numRef>
+              <c:f>'Chart Data'!$D$2:$D$5</c:f>
+              <c:numCache>
+                <c:formatCode>0</c:formatCode>
+                <c:ptCount val="4"/>
+                <c:pt idx="0">
+                  <c:v>490</c:v>
+                </c:pt>
+                <c:pt idx="1">
+                  <c:v>483</c:v>
+                </c:pt>
+                <c:pt idx="2">
+                  <c:v>476</c:v>
+                </c:pt>
+                <c:pt idx="3">
+                  <c:v>469</c:v>
                 </c:pt>
               </c:numCache>
             </c:numRef>
@@ -4124,6 +4667,23 @@
         <c:crossBetween val="between"/>
       </c:valAx>
     </c:plotArea>
+    <c:legend>
+      <c:legendPos val="b"/>
+      <c:overlay val="0"/>
+      <c:txPr>
+        <a:bodyPr xmlns:a="http://schemas.openxmlformats.org/drawingml/2006/main" anchorCtr="1"/>
+        <a:lstStyle xmlns:a="http://schemas.openxmlformats.org/drawingml/2006/main"/>
+        <a:p xmlns:a="http://schemas.openxmlformats.org/drawingml/2006/main">
+          <a:pPr>
+            <a:defRPr sz="1275">
+              <a:latin typeface="Arial"/>
+              <a:ea typeface="Arial"/>
+              <a:cs typeface="Arial"/>
+            </a:defRPr>
+          </a:pPr>
+        </a:p>
+      </c:txPr>
+    </c:legend>
     <c:plotVisOnly val="1"/>
   </c:chart>
   <c:externalData r:id="rIdChartSnapshot1">
@@ -4322,7 +4882,7 @@
           <c:idx val="0"/>
           <c:order val="0"/>
           <c:tx>
-            <c:v>ASP</c:v>
+            <c:v>Company</c:v>
           </c:tx>
           <c:spPr>
             <a:solidFill xmlns:a="http://schemas.openxmlformats.org/drawingml/2006/main">
@@ -4374,6 +4934,69 @@
                 </c:pt>
                 <c:pt idx="3">
                   <c:v>612</c:v>
+                </c:pt>
+              </c:numCache>
+            </c:numRef>
+          </c:val>
+          <c:smooth val="0"/>
+        </c:ser>
+        <c:ser>
+          <c:idx val="1"/>
+          <c:order val="1"/>
+          <c:tx>
+            <c:v>Market average</c:v>
+          </c:tx>
+          <c:spPr>
+            <a:solidFill xmlns:a="http://schemas.openxmlformats.org/drawingml/2006/main">
+              <a:srgbClr val="A85D24"/>
+            </a:solidFill>
+            <a:ln xmlns:a="http://schemas.openxmlformats.org/drawingml/2006/main" w="28575">
+              <a:solidFill>
+                <a:srgbClr val="A85D24"/>
+              </a:solidFill>
+              <a:prstDash val="dash"/>
+            </a:ln>
+          </c:spPr>
+          <c:marker>
+            <c:symbol val="none"/>
+          </c:marker>
+          <c:cat>
+            <c:strRef>
+              <c:f>'Chart Data'!$C$2:$C$5</c:f>
+              <c:strCache>
+                <c:ptCount val="4"/>
+                <c:pt idx="0">
+                  <c:v>Q1</c:v>
+                </c:pt>
+                <c:pt idx="1">
+                  <c:v>Q2</c:v>
+                </c:pt>
+                <c:pt idx="2">
+                  <c:v>Q3</c:v>
+                </c:pt>
+                <c:pt idx="3">
+                  <c:v>Q4</c:v>
+                </c:pt>
+              </c:strCache>
+            </c:strRef>
+          </c:cat>
+          <c:val>
+            <c:numRef>
+              <c:f>'Chart Data'!$D$2:$D$5</c:f>
+              <c:numCache>
+                <c:formatCode>0</c:formatCode>
+                <c:ptCount val="4"/>
+                <c:pt idx="0">
+                  <c:v>565</c:v>
+                </c:pt>
+                <c:pt idx="1">
+                  <c:v>558</c:v>
+                </c:pt>
+                <c:pt idx="2">
+                  <c:v>551</c:v>
+                </c:pt>
+                <c:pt idx="3">
+                  <c:v>544</c:v>
                 </c:pt>
               </c:numCache>
             </c:numRef>
@@ -4480,6 +5103,23 @@
         <c:crossBetween val="between"/>
       </c:valAx>
     </c:plotArea>
+    <c:legend>
+      <c:legendPos val="b"/>
+      <c:overlay val="0"/>
+      <c:txPr>
+        <a:bodyPr xmlns:a="http://schemas.openxmlformats.org/drawingml/2006/main" anchorCtr="1"/>
+        <a:lstStyle xmlns:a="http://schemas.openxmlformats.org/drawingml/2006/main"/>
+        <a:p xmlns:a="http://schemas.openxmlformats.org/drawingml/2006/main">
+          <a:pPr>
+            <a:defRPr sz="1275">
+              <a:latin typeface="Arial"/>
+              <a:ea typeface="Arial"/>
+              <a:cs typeface="Arial"/>
+            </a:defRPr>
+          </a:pPr>
+        </a:p>
+      </c:txPr>
+    </c:legend>
     <c:plotVisOnly val="1"/>
   </c:chart>
   <c:externalData r:id="rIdChartSnapshot1">
@@ -4678,7 +5318,7 @@
           <c:idx val="0"/>
           <c:order val="0"/>
           <c:tx>
-            <c:v>ASP</c:v>
+            <c:v>Company</c:v>
           </c:tx>
           <c:spPr>
             <a:solidFill xmlns:a="http://schemas.openxmlformats.org/drawingml/2006/main">
@@ -4730,6 +5370,69 @@
                 </c:pt>
                 <c:pt idx="3">
                   <c:v>697</c:v>
+                </c:pt>
+              </c:numCache>
+            </c:numRef>
+          </c:val>
+          <c:smooth val="0"/>
+        </c:ser>
+        <c:ser>
+          <c:idx val="1"/>
+          <c:order val="1"/>
+          <c:tx>
+            <c:v>Market average</c:v>
+          </c:tx>
+          <c:spPr>
+            <a:solidFill xmlns:a="http://schemas.openxmlformats.org/drawingml/2006/main">
+              <a:srgbClr val="A85D24"/>
+            </a:solidFill>
+            <a:ln xmlns:a="http://schemas.openxmlformats.org/drawingml/2006/main" w="28575">
+              <a:solidFill>
+                <a:srgbClr val="A85D24"/>
+              </a:solidFill>
+              <a:prstDash val="dash"/>
+            </a:ln>
+          </c:spPr>
+          <c:marker>
+            <c:symbol val="none"/>
+          </c:marker>
+          <c:cat>
+            <c:strRef>
+              <c:f>'Chart Data'!$C$2:$C$5</c:f>
+              <c:strCache>
+                <c:ptCount val="4"/>
+                <c:pt idx="0">
+                  <c:v>Q1</c:v>
+                </c:pt>
+                <c:pt idx="1">
+                  <c:v>Q2</c:v>
+                </c:pt>
+                <c:pt idx="2">
+                  <c:v>Q3</c:v>
+                </c:pt>
+                <c:pt idx="3">
+                  <c:v>Q4</c:v>
+                </c:pt>
+              </c:strCache>
+            </c:strRef>
+          </c:cat>
+          <c:val>
+            <c:numRef>
+              <c:f>'Chart Data'!$D$2:$D$5</c:f>
+              <c:numCache>
+                <c:formatCode>0</c:formatCode>
+                <c:ptCount val="4"/>
+                <c:pt idx="0">
+                  <c:v>650</c:v>
+                </c:pt>
+                <c:pt idx="1">
+                  <c:v>643</c:v>
+                </c:pt>
+                <c:pt idx="2">
+                  <c:v>636</c:v>
+                </c:pt>
+                <c:pt idx="3">
+                  <c:v>629</c:v>
                 </c:pt>
               </c:numCache>
             </c:numRef>
@@ -4836,6 +5539,23 @@
         <c:crossBetween val="between"/>
       </c:valAx>
     </c:plotArea>
+    <c:legend>
+      <c:legendPos val="b"/>
+      <c:overlay val="0"/>
+      <c:txPr>
+        <a:bodyPr xmlns:a="http://schemas.openxmlformats.org/drawingml/2006/main" anchorCtr="1"/>
+        <a:lstStyle xmlns:a="http://schemas.openxmlformats.org/drawingml/2006/main"/>
+        <a:p xmlns:a="http://schemas.openxmlformats.org/drawingml/2006/main">
+          <a:pPr>
+            <a:defRPr sz="1275">
+              <a:latin typeface="Arial"/>
+              <a:ea typeface="Arial"/>
+              <a:cs typeface="Arial"/>
+            </a:defRPr>
+          </a:pPr>
+        </a:p>
+      </c:txPr>
+    </c:legend>
     <c:plotVisOnly val="1"/>
   </c:chart>
   <c:externalData r:id="rIdChartSnapshot1">
@@ -5034,7 +5754,7 @@
           <c:idx val="0"/>
           <c:order val="0"/>
           <c:tx>
-            <c:v>ASP</c:v>
+            <c:v>Company</c:v>
           </c:tx>
           <c:spPr>
             <a:solidFill xmlns:a="http://schemas.openxmlformats.org/drawingml/2006/main">
@@ -5086,6 +5806,69 @@
                 </c:pt>
                 <c:pt idx="3">
                   <c:v>601</c:v>
+                </c:pt>
+              </c:numCache>
+            </c:numRef>
+          </c:val>
+          <c:smooth val="0"/>
+        </c:ser>
+        <c:ser>
+          <c:idx val="1"/>
+          <c:order val="1"/>
+          <c:tx>
+            <c:v>Market average</c:v>
+          </c:tx>
+          <c:spPr>
+            <a:solidFill xmlns:a="http://schemas.openxmlformats.org/drawingml/2006/main">
+              <a:srgbClr val="A85D24"/>
+            </a:solidFill>
+            <a:ln xmlns:a="http://schemas.openxmlformats.org/drawingml/2006/main" w="28575">
+              <a:solidFill>
+                <a:srgbClr val="A85D24"/>
+              </a:solidFill>
+              <a:prstDash val="dash"/>
+            </a:ln>
+          </c:spPr>
+          <c:marker>
+            <c:symbol val="none"/>
+          </c:marker>
+          <c:cat>
+            <c:strRef>
+              <c:f>'Chart Data'!$C$2:$C$5</c:f>
+              <c:strCache>
+                <c:ptCount val="4"/>
+                <c:pt idx="0">
+                  <c:v>Q1</c:v>
+                </c:pt>
+                <c:pt idx="1">
+                  <c:v>Q2</c:v>
+                </c:pt>
+                <c:pt idx="2">
+                  <c:v>Q3</c:v>
+                </c:pt>
+                <c:pt idx="3">
+                  <c:v>Q4</c:v>
+                </c:pt>
+              </c:strCache>
+            </c:strRef>
+          </c:cat>
+          <c:val>
+            <c:numRef>
+              <c:f>'Chart Data'!$D$2:$D$5</c:f>
+              <c:numCache>
+                <c:formatCode>0</c:formatCode>
+                <c:ptCount val="4"/>
+                <c:pt idx="0">
+                  <c:v>530</c:v>
+                </c:pt>
+                <c:pt idx="1">
+                  <c:v>527</c:v>
+                </c:pt>
+                <c:pt idx="2">
+                  <c:v>524</c:v>
+                </c:pt>
+                <c:pt idx="3">
+                  <c:v>521</c:v>
                 </c:pt>
               </c:numCache>
             </c:numRef>
@@ -5192,6 +5975,23 @@
         <c:crossBetween val="between"/>
       </c:valAx>
     </c:plotArea>
+    <c:legend>
+      <c:legendPos val="b"/>
+      <c:overlay val="0"/>
+      <c:txPr>
+        <a:bodyPr xmlns:a="http://schemas.openxmlformats.org/drawingml/2006/main" anchorCtr="1"/>
+        <a:lstStyle xmlns:a="http://schemas.openxmlformats.org/drawingml/2006/main"/>
+        <a:p xmlns:a="http://schemas.openxmlformats.org/drawingml/2006/main">
+          <a:pPr>
+            <a:defRPr sz="1275">
+              <a:latin typeface="Arial"/>
+              <a:ea typeface="Arial"/>
+              <a:cs typeface="Arial"/>
+            </a:defRPr>
+          </a:pPr>
+        </a:p>
+      </c:txPr>
+    </c:legend>
     <c:plotVisOnly val="1"/>
   </c:chart>
   <c:externalData r:id="rIdChartSnapshot1">
@@ -5390,7 +6190,7 @@
           <c:idx val="0"/>
           <c:order val="0"/>
           <c:tx>
-            <c:v>ASP</c:v>
+            <c:v>Company</c:v>
           </c:tx>
           <c:spPr>
             <a:solidFill xmlns:a="http://schemas.openxmlformats.org/drawingml/2006/main">
@@ -5442,6 +6242,69 @@
                 </c:pt>
                 <c:pt idx="3">
                   <c:v>676</c:v>
+                </c:pt>
+              </c:numCache>
+            </c:numRef>
+          </c:val>
+          <c:smooth val="0"/>
+        </c:ser>
+        <c:ser>
+          <c:idx val="1"/>
+          <c:order val="1"/>
+          <c:tx>
+            <c:v>Market average</c:v>
+          </c:tx>
+          <c:spPr>
+            <a:solidFill xmlns:a="http://schemas.openxmlformats.org/drawingml/2006/main">
+              <a:srgbClr val="A85D24"/>
+            </a:solidFill>
+            <a:ln xmlns:a="http://schemas.openxmlformats.org/drawingml/2006/main" w="28575">
+              <a:solidFill>
+                <a:srgbClr val="A85D24"/>
+              </a:solidFill>
+              <a:prstDash val="dash"/>
+            </a:ln>
+          </c:spPr>
+          <c:marker>
+            <c:symbol val="none"/>
+          </c:marker>
+          <c:cat>
+            <c:strRef>
+              <c:f>'Chart Data'!$C$2:$C$5</c:f>
+              <c:strCache>
+                <c:ptCount val="4"/>
+                <c:pt idx="0">
+                  <c:v>Q1</c:v>
+                </c:pt>
+                <c:pt idx="1">
+                  <c:v>Q2</c:v>
+                </c:pt>
+                <c:pt idx="2">
+                  <c:v>Q3</c:v>
+                </c:pt>
+                <c:pt idx="3">
+                  <c:v>Q4</c:v>
+                </c:pt>
+              </c:strCache>
+            </c:strRef>
+          </c:cat>
+          <c:val>
+            <c:numRef>
+              <c:f>'Chart Data'!$D$2:$D$5</c:f>
+              <c:numCache>
+                <c:formatCode>0</c:formatCode>
+                <c:ptCount val="4"/>
+                <c:pt idx="0">
+                  <c:v>605</c:v>
+                </c:pt>
+                <c:pt idx="1">
+                  <c:v>602</c:v>
+                </c:pt>
+                <c:pt idx="2">
+                  <c:v>599</c:v>
+                </c:pt>
+                <c:pt idx="3">
+                  <c:v>596</c:v>
                 </c:pt>
               </c:numCache>
             </c:numRef>
@@ -5548,6 +6411,23 @@
         <c:crossBetween val="between"/>
       </c:valAx>
     </c:plotArea>
+    <c:legend>
+      <c:legendPos val="b"/>
+      <c:overlay val="0"/>
+      <c:txPr>
+        <a:bodyPr xmlns:a="http://schemas.openxmlformats.org/drawingml/2006/main" anchorCtr="1"/>
+        <a:lstStyle xmlns:a="http://schemas.openxmlformats.org/drawingml/2006/main"/>
+        <a:p xmlns:a="http://schemas.openxmlformats.org/drawingml/2006/main">
+          <a:pPr>
+            <a:defRPr sz="1275">
+              <a:latin typeface="Arial"/>
+              <a:ea typeface="Arial"/>
+              <a:cs typeface="Arial"/>
+            </a:defRPr>
+          </a:pPr>
+        </a:p>
+      </c:txPr>
+    </c:legend>
     <c:plotVisOnly val="1"/>
   </c:chart>
   <c:externalData r:id="rIdChartSnapshot1">
@@ -5746,7 +6626,7 @@
           <c:idx val="0"/>
           <c:order val="0"/>
           <c:tx>
-            <c:v>ASP</c:v>
+            <c:v>Company</c:v>
           </c:tx>
           <c:spPr>
             <a:solidFill xmlns:a="http://schemas.openxmlformats.org/drawingml/2006/main">
@@ -5798,6 +6678,69 @@
                 </c:pt>
                 <c:pt idx="3">
                   <c:v>761</c:v>
+                </c:pt>
+              </c:numCache>
+            </c:numRef>
+          </c:val>
+          <c:smooth val="0"/>
+        </c:ser>
+        <c:ser>
+          <c:idx val="1"/>
+          <c:order val="1"/>
+          <c:tx>
+            <c:v>Market average</c:v>
+          </c:tx>
+          <c:spPr>
+            <a:solidFill xmlns:a="http://schemas.openxmlformats.org/drawingml/2006/main">
+              <a:srgbClr val="A85D24"/>
+            </a:solidFill>
+            <a:ln xmlns:a="http://schemas.openxmlformats.org/drawingml/2006/main" w="28575">
+              <a:solidFill>
+                <a:srgbClr val="A85D24"/>
+              </a:solidFill>
+              <a:prstDash val="dash"/>
+            </a:ln>
+          </c:spPr>
+          <c:marker>
+            <c:symbol val="none"/>
+          </c:marker>
+          <c:cat>
+            <c:strRef>
+              <c:f>'Chart Data'!$C$2:$C$5</c:f>
+              <c:strCache>
+                <c:ptCount val="4"/>
+                <c:pt idx="0">
+                  <c:v>Q1</c:v>
+                </c:pt>
+                <c:pt idx="1">
+                  <c:v>Q2</c:v>
+                </c:pt>
+                <c:pt idx="2">
+                  <c:v>Q3</c:v>
+                </c:pt>
+                <c:pt idx="3">
+                  <c:v>Q4</c:v>
+                </c:pt>
+              </c:strCache>
+            </c:strRef>
+          </c:cat>
+          <c:val>
+            <c:numRef>
+              <c:f>'Chart Data'!$D$2:$D$5</c:f>
+              <c:numCache>
+                <c:formatCode>0</c:formatCode>
+                <c:ptCount val="4"/>
+                <c:pt idx="0">
+                  <c:v>690</c:v>
+                </c:pt>
+                <c:pt idx="1">
+                  <c:v>687</c:v>
+                </c:pt>
+                <c:pt idx="2">
+                  <c:v>684</c:v>
+                </c:pt>
+                <c:pt idx="3">
+                  <c:v>681</c:v>
                 </c:pt>
               </c:numCache>
             </c:numRef>
@@ -5904,6 +6847,23 @@
         <c:crossBetween val="between"/>
       </c:valAx>
     </c:plotArea>
+    <c:legend>
+      <c:legendPos val="b"/>
+      <c:overlay val="0"/>
+      <c:txPr>
+        <a:bodyPr xmlns:a="http://schemas.openxmlformats.org/drawingml/2006/main" anchorCtr="1"/>
+        <a:lstStyle xmlns:a="http://schemas.openxmlformats.org/drawingml/2006/main"/>
+        <a:p xmlns:a="http://schemas.openxmlformats.org/drawingml/2006/main">
+          <a:pPr>
+            <a:defRPr sz="1275">
+              <a:latin typeface="Arial"/>
+              <a:ea typeface="Arial"/>
+              <a:cs typeface="Arial"/>
+            </a:defRPr>
+          </a:pPr>
+        </a:p>
+      </c:txPr>
+    </c:legend>
     <c:plotVisOnly val="1"/>
   </c:chart>
   <c:externalData r:id="rIdChartSnapshot1">
@@ -6114,7 +7074,7 @@
           <p:cNvPr id="11" name="">
             <a:extLst xmlns:a="http://schemas.openxmlformats.org/drawingml/2006/main">
               <a:ext uri="{FF2B5EF4-FFF2-40B4-BE49-F238E27FC236}">
-                <a16:creationId xmlns:a16="http://schemas.microsoft.com/office/drawing/2014/main" id="{7A24EB7A-B686-4F50-9F3F-E5E50B6FD568}"/>
+                <a16:creationId xmlns:a16="http://schemas.microsoft.com/office/drawing/2014/main" id="{3C78B5EC-BAD3-40F5-851F-2138E6F23DAC}"/>
               </a:ext>
             </a:extLst>
           </p:cNvPr>
@@ -6171,7 +7131,7 @@
           <p:cNvPr id="2" name="">
             <a:extLst xmlns:a="http://schemas.openxmlformats.org/drawingml/2006/main">
               <a:ext uri="{FF2B5EF4-FFF2-40B4-BE49-F238E27FC236}">
-                <a16:creationId xmlns:a16="http://schemas.microsoft.com/office/drawing/2014/main" id="{6F646160-9BE6-4667-9F11-9505679A33E5}"/>
+                <a16:creationId xmlns:a16="http://schemas.microsoft.com/office/drawing/2014/main" id="{13732A54-0601-4450-9A04-9EA38DF75B38}"/>
               </a:ext>
             </a:extLst>
           </p:cNvPr>
@@ -6228,7 +7188,7 @@
           <p:cNvPr id="3" name="">
             <a:extLst xmlns:a="http://schemas.openxmlformats.org/drawingml/2006/main">
               <a:ext uri="{FF2B5EF4-FFF2-40B4-BE49-F238E27FC236}">
-                <a16:creationId xmlns:a16="http://schemas.microsoft.com/office/drawing/2014/main" id="{AE0863B6-B5A1-4C12-8FE4-FCDA74C607A9}"/>
+                <a16:creationId xmlns:a16="http://schemas.microsoft.com/office/drawing/2014/main" id="{02E1FD99-3639-4D2E-BE52-377713B794E1}"/>
               </a:ext>
             </a:extLst>
           </p:cNvPr>
@@ -6285,7 +7245,7 @@
           <p:cNvPr id="4" name="">
             <a:extLst xmlns:a="http://schemas.openxmlformats.org/drawingml/2006/main">
               <a:ext uri="{FF2B5EF4-FFF2-40B4-BE49-F238E27FC236}">
-                <a16:creationId xmlns:a16="http://schemas.microsoft.com/office/drawing/2014/main" id="{C9D77879-B2A9-444E-BFC0-2F95227FB4A4}"/>
+                <a16:creationId xmlns:a16="http://schemas.microsoft.com/office/drawing/2014/main" id="{C67ACC91-6FD6-46E7-BDEE-F06B9D5EC504}"/>
               </a:ext>
             </a:extLst>
           </p:cNvPr>
@@ -6342,7 +7302,7 @@
           <p:cNvPr id="5" name="">
             <a:extLst xmlns:a="http://schemas.openxmlformats.org/drawingml/2006/main">
               <a:ext uri="{FF2B5EF4-FFF2-40B4-BE49-F238E27FC236}">
-                <a16:creationId xmlns:a16="http://schemas.microsoft.com/office/drawing/2014/main" id="{4D5A8E78-2D71-4ABA-BD51-88497A05D3DD}"/>
+                <a16:creationId xmlns:a16="http://schemas.microsoft.com/office/drawing/2014/main" id="{55BB4249-05FB-4CCC-8DF0-BF08D7418C67}"/>
               </a:ext>
             </a:extLst>
           </p:cNvPr>
@@ -6406,7 +7366,7 @@
         </p:xfrm>
         <a:graphic xmlns:a="http://schemas.openxmlformats.org/drawingml/2006/main">
           <a:graphicData uri="http://schemas.openxmlformats.org/drawingml/2006/chart">
-            <c:chart xmlns:r="http://schemas.openxmlformats.org/officeDocument/2006/relationships" xmlns:c="http://schemas.openxmlformats.org/drawingml/2006/chart" r:id="Reb1d00bc5b944125"/>
+            <c:chart xmlns:r="http://schemas.openxmlformats.org/officeDocument/2006/relationships" xmlns:c="http://schemas.openxmlformats.org/drawingml/2006/chart" r:id="R9d842f5f9afe421c"/>
           </a:graphicData>
         </a:graphic>
       </p:graphicFrame>
@@ -6422,7 +7382,7 @@
         </p:xfrm>
         <a:graphic xmlns:a="http://schemas.openxmlformats.org/drawingml/2006/main">
           <a:graphicData uri="http://schemas.openxmlformats.org/drawingml/2006/chart">
-            <c:chart xmlns:r="http://schemas.openxmlformats.org/officeDocument/2006/relationships" xmlns:c="http://schemas.openxmlformats.org/drawingml/2006/chart" r:id="R381f9c0173844172"/>
+            <c:chart xmlns:r="http://schemas.openxmlformats.org/officeDocument/2006/relationships" xmlns:c="http://schemas.openxmlformats.org/drawingml/2006/chart" r:id="R5af1be8c5a4d4461"/>
           </a:graphicData>
         </a:graphic>
       </p:graphicFrame>
@@ -6431,7 +7391,7 @@
           <p:cNvPr id="8" name="">
             <a:extLst xmlns:a="http://schemas.openxmlformats.org/drawingml/2006/main">
               <a:ext uri="{FF2B5EF4-FFF2-40B4-BE49-F238E27FC236}">
-                <a16:creationId xmlns:a16="http://schemas.microsoft.com/office/drawing/2014/main" id="{48B7A72F-8CBC-4442-AC54-BA9E810DB79F}"/>
+                <a16:creationId xmlns:a16="http://schemas.microsoft.com/office/drawing/2014/main" id="{392C9DA8-DE74-47E2-81B2-F16D6DBB9AF9}"/>
               </a:ext>
             </a:extLst>
           </p:cNvPr>
@@ -6478,7 +7438,7 @@
                 <a:ea typeface="Arial"/>
                 <a:cs typeface="Arial"/>
               </a:rPr>
-              <a:t>Market share = company units / market units. ASP = revenue / company units.</a:t>
+              <a:t>ASP = revenue / units for company and total market (including company).</a:t>
             </a:r>
           </a:p>
         </p:txBody>
@@ -6488,7 +7448,7 @@
           <p:cNvPr id="9" name="">
             <a:extLst xmlns:a="http://schemas.openxmlformats.org/drawingml/2006/main">
               <a:ext uri="{FF2B5EF4-FFF2-40B4-BE49-F238E27FC236}">
-                <a16:creationId xmlns:a16="http://schemas.microsoft.com/office/drawing/2014/main" id="{5F1DE02C-12B6-42EB-93FC-FB6326672A2A}"/>
+                <a16:creationId xmlns:a16="http://schemas.microsoft.com/office/drawing/2014/main" id="{D460DD26-4CEE-4E81-A6E9-808C305A4E0A}"/>
               </a:ext>
             </a:extLst>
           </p:cNvPr>
@@ -6545,7 +7505,7 @@
           <p:cNvPr id="10" name="">
             <a:extLst xmlns:a="http://schemas.openxmlformats.org/drawingml/2006/main">
               <a:ext uri="{FF2B5EF4-FFF2-40B4-BE49-F238E27FC236}">
-                <a16:creationId xmlns:a16="http://schemas.microsoft.com/office/drawing/2014/main" id="{AF28AFC8-7654-4313-9D43-1A4DCD5FB058}"/>
+                <a16:creationId xmlns:a16="http://schemas.microsoft.com/office/drawing/2014/main" id="{7EBCD534-4C21-4BD5-8FB0-0DD947AB7CD8}"/>
               </a:ext>
             </a:extLst>
           </p:cNvPr>
@@ -6600,7 +7560,7 @@
     </p:spTree>
     <p:extLst>
       <p:ext uri="{BB962C8B-B14F-4D97-AF65-F5344CB8AC3E}">
-        <p14:creationId xmlns:p14="http://schemas.microsoft.com/office/powerpoint/2010/main" val="553395177"/>
+        <p14:creationId xmlns:p14="http://schemas.microsoft.com/office/powerpoint/2010/main" val="1214244615"/>
       </p:ext>
     </p:extLst>
   </p:cSld>
@@ -6631,7 +7591,7 @@
           <p:cNvPr id="11" name="">
             <a:extLst xmlns:a="http://schemas.openxmlformats.org/drawingml/2006/main">
               <a:ext uri="{FF2B5EF4-FFF2-40B4-BE49-F238E27FC236}">
-                <a16:creationId xmlns:a16="http://schemas.microsoft.com/office/drawing/2014/main" id="{35ADE4FD-B70D-48FA-B5CE-4C005D17D993}"/>
+                <a16:creationId xmlns:a16="http://schemas.microsoft.com/office/drawing/2014/main" id="{7A8B4340-5A00-4602-956C-E30135F77BD8}"/>
               </a:ext>
             </a:extLst>
           </p:cNvPr>
@@ -6688,7 +7648,7 @@
           <p:cNvPr id="2" name="">
             <a:extLst xmlns:a="http://schemas.openxmlformats.org/drawingml/2006/main">
               <a:ext uri="{FF2B5EF4-FFF2-40B4-BE49-F238E27FC236}">
-                <a16:creationId xmlns:a16="http://schemas.microsoft.com/office/drawing/2014/main" id="{8E671977-0262-4B74-9C43-4DFE53123CE4}"/>
+                <a16:creationId xmlns:a16="http://schemas.microsoft.com/office/drawing/2014/main" id="{ABB755D6-0D5C-47BD-9C82-6987CFA9F734}"/>
               </a:ext>
             </a:extLst>
           </p:cNvPr>
@@ -6745,7 +7705,7 @@
           <p:cNvPr id="3" name="">
             <a:extLst xmlns:a="http://schemas.openxmlformats.org/drawingml/2006/main">
               <a:ext uri="{FF2B5EF4-FFF2-40B4-BE49-F238E27FC236}">
-                <a16:creationId xmlns:a16="http://schemas.microsoft.com/office/drawing/2014/main" id="{3FCE5A74-18E8-4076-B63B-7B4D9C846C0E}"/>
+                <a16:creationId xmlns:a16="http://schemas.microsoft.com/office/drawing/2014/main" id="{F73B00CA-46BE-471F-98E0-D723D4E7AFB6}"/>
               </a:ext>
             </a:extLst>
           </p:cNvPr>
@@ -6802,7 +7762,7 @@
           <p:cNvPr id="4" name="">
             <a:extLst xmlns:a="http://schemas.openxmlformats.org/drawingml/2006/main">
               <a:ext uri="{FF2B5EF4-FFF2-40B4-BE49-F238E27FC236}">
-                <a16:creationId xmlns:a16="http://schemas.microsoft.com/office/drawing/2014/main" id="{52B67990-9565-42DF-9EC2-93967DF83683}"/>
+                <a16:creationId xmlns:a16="http://schemas.microsoft.com/office/drawing/2014/main" id="{0E2B3455-EADF-4EBC-94C3-E30B016F324D}"/>
               </a:ext>
             </a:extLst>
           </p:cNvPr>
@@ -6859,7 +7819,7 @@
           <p:cNvPr id="5" name="">
             <a:extLst xmlns:a="http://schemas.openxmlformats.org/drawingml/2006/main">
               <a:ext uri="{FF2B5EF4-FFF2-40B4-BE49-F238E27FC236}">
-                <a16:creationId xmlns:a16="http://schemas.microsoft.com/office/drawing/2014/main" id="{4C3CC3E6-9FED-4171-B96F-8EA9F317B97F}"/>
+                <a16:creationId xmlns:a16="http://schemas.microsoft.com/office/drawing/2014/main" id="{70BCC462-33AE-4BB5-9B1F-CACF8C562E09}"/>
               </a:ext>
             </a:extLst>
           </p:cNvPr>
@@ -6923,7 +7883,7 @@
         </p:xfrm>
         <a:graphic xmlns:a="http://schemas.openxmlformats.org/drawingml/2006/main">
           <a:graphicData uri="http://schemas.openxmlformats.org/drawingml/2006/chart">
-            <c:chart xmlns:r="http://schemas.openxmlformats.org/officeDocument/2006/relationships" xmlns:c="http://schemas.openxmlformats.org/drawingml/2006/chart" r:id="Reeb56b9022304e92"/>
+            <c:chart xmlns:r="http://schemas.openxmlformats.org/officeDocument/2006/relationships" xmlns:c="http://schemas.openxmlformats.org/drawingml/2006/chart" r:id="Ra7e6674e49a3485d"/>
           </a:graphicData>
         </a:graphic>
       </p:graphicFrame>
@@ -6939,7 +7899,7 @@
         </p:xfrm>
         <a:graphic xmlns:a="http://schemas.openxmlformats.org/drawingml/2006/main">
           <a:graphicData uri="http://schemas.openxmlformats.org/drawingml/2006/chart">
-            <c:chart xmlns:r="http://schemas.openxmlformats.org/officeDocument/2006/relationships" xmlns:c="http://schemas.openxmlformats.org/drawingml/2006/chart" r:id="Re3a42e84a4364925"/>
+            <c:chart xmlns:r="http://schemas.openxmlformats.org/officeDocument/2006/relationships" xmlns:c="http://schemas.openxmlformats.org/drawingml/2006/chart" r:id="R4af829b084764ef8"/>
           </a:graphicData>
         </a:graphic>
       </p:graphicFrame>
@@ -6948,7 +7908,7 @@
           <p:cNvPr id="8" name="">
             <a:extLst xmlns:a="http://schemas.openxmlformats.org/drawingml/2006/main">
               <a:ext uri="{FF2B5EF4-FFF2-40B4-BE49-F238E27FC236}">
-                <a16:creationId xmlns:a16="http://schemas.microsoft.com/office/drawing/2014/main" id="{18598BE3-DB50-46BF-991D-7EED038EF5B5}"/>
+                <a16:creationId xmlns:a16="http://schemas.microsoft.com/office/drawing/2014/main" id="{32F76D61-0ADE-4A36-9632-1C3A1E714E45}"/>
               </a:ext>
             </a:extLst>
           </p:cNvPr>
@@ -6995,7 +7955,7 @@
                 <a:ea typeface="Arial"/>
                 <a:cs typeface="Arial"/>
               </a:rPr>
-              <a:t>Market share = company units / market units. ASP = revenue / company units.</a:t>
+              <a:t>ASP = revenue / units for company and total market (including company).</a:t>
             </a:r>
           </a:p>
         </p:txBody>
@@ -7005,7 +7965,7 @@
           <p:cNvPr id="9" name="">
             <a:extLst xmlns:a="http://schemas.openxmlformats.org/drawingml/2006/main">
               <a:ext uri="{FF2B5EF4-FFF2-40B4-BE49-F238E27FC236}">
-                <a16:creationId xmlns:a16="http://schemas.microsoft.com/office/drawing/2014/main" id="{B4B13336-2FD6-4EA7-BCEA-6EFC562A8CBD}"/>
+                <a16:creationId xmlns:a16="http://schemas.microsoft.com/office/drawing/2014/main" id="{2E5480C6-E340-4D36-BFE5-2F63CED05E13}"/>
               </a:ext>
             </a:extLst>
           </p:cNvPr>
@@ -7062,7 +8022,7 @@
           <p:cNvPr id="10" name="">
             <a:extLst xmlns:a="http://schemas.openxmlformats.org/drawingml/2006/main">
               <a:ext uri="{FF2B5EF4-FFF2-40B4-BE49-F238E27FC236}">
-                <a16:creationId xmlns:a16="http://schemas.microsoft.com/office/drawing/2014/main" id="{9BAFB55B-AD38-4D84-B0D1-03AB42F19CCB}"/>
+                <a16:creationId xmlns:a16="http://schemas.microsoft.com/office/drawing/2014/main" id="{ADEFF563-C81F-44F7-A716-73EFF856FC8F}"/>
               </a:ext>
             </a:extLst>
           </p:cNvPr>
@@ -7117,7 +8077,7 @@
     </p:spTree>
     <p:extLst>
       <p:ext uri="{BB962C8B-B14F-4D97-AF65-F5344CB8AC3E}">
-        <p14:creationId xmlns:p14="http://schemas.microsoft.com/office/powerpoint/2010/main" val="658562832"/>
+        <p14:creationId xmlns:p14="http://schemas.microsoft.com/office/powerpoint/2010/main" val="1593614985"/>
       </p:ext>
     </p:extLst>
   </p:cSld>
@@ -7148,7 +8108,7 @@
           <p:cNvPr id="11" name="">
             <a:extLst xmlns:a="http://schemas.openxmlformats.org/drawingml/2006/main">
               <a:ext uri="{FF2B5EF4-FFF2-40B4-BE49-F238E27FC236}">
-                <a16:creationId xmlns:a16="http://schemas.microsoft.com/office/drawing/2014/main" id="{4CD37162-BC51-4E66-A85A-F0E77207C88F}"/>
+                <a16:creationId xmlns:a16="http://schemas.microsoft.com/office/drawing/2014/main" id="{1EF704C7-119A-4822-BCA8-C3EACE773405}"/>
               </a:ext>
             </a:extLst>
           </p:cNvPr>
@@ -7205,7 +8165,7 @@
           <p:cNvPr id="2" name="">
             <a:extLst xmlns:a="http://schemas.openxmlformats.org/drawingml/2006/main">
               <a:ext uri="{FF2B5EF4-FFF2-40B4-BE49-F238E27FC236}">
-                <a16:creationId xmlns:a16="http://schemas.microsoft.com/office/drawing/2014/main" id="{B74F1389-0F7A-4A7D-B9DE-4C28489EA873}"/>
+                <a16:creationId xmlns:a16="http://schemas.microsoft.com/office/drawing/2014/main" id="{D0D0560D-F0AD-448E-839A-EDD484BAAE31}"/>
               </a:ext>
             </a:extLst>
           </p:cNvPr>
@@ -7262,7 +8222,7 @@
           <p:cNvPr id="3" name="">
             <a:extLst xmlns:a="http://schemas.openxmlformats.org/drawingml/2006/main">
               <a:ext uri="{FF2B5EF4-FFF2-40B4-BE49-F238E27FC236}">
-                <a16:creationId xmlns:a16="http://schemas.microsoft.com/office/drawing/2014/main" id="{7CC2E820-5996-4E71-B36C-43376502F5ED}"/>
+                <a16:creationId xmlns:a16="http://schemas.microsoft.com/office/drawing/2014/main" id="{583AED52-2528-491B-93B9-20922378E4D8}"/>
               </a:ext>
             </a:extLst>
           </p:cNvPr>
@@ -7319,7 +8279,7 @@
           <p:cNvPr id="4" name="">
             <a:extLst xmlns:a="http://schemas.openxmlformats.org/drawingml/2006/main">
               <a:ext uri="{FF2B5EF4-FFF2-40B4-BE49-F238E27FC236}">
-                <a16:creationId xmlns:a16="http://schemas.microsoft.com/office/drawing/2014/main" id="{DA7ABC3F-E3D5-43A4-9670-CC1C0EF17B82}"/>
+                <a16:creationId xmlns:a16="http://schemas.microsoft.com/office/drawing/2014/main" id="{AA77E20C-5C65-4666-9DB6-C0F8DC1CF0E6}"/>
               </a:ext>
             </a:extLst>
           </p:cNvPr>
@@ -7376,7 +8336,7 @@
           <p:cNvPr id="5" name="">
             <a:extLst xmlns:a="http://schemas.openxmlformats.org/drawingml/2006/main">
               <a:ext uri="{FF2B5EF4-FFF2-40B4-BE49-F238E27FC236}">
-                <a16:creationId xmlns:a16="http://schemas.microsoft.com/office/drawing/2014/main" id="{ADBD2139-39D7-4929-994A-6C8C3A45E3F7}"/>
+                <a16:creationId xmlns:a16="http://schemas.microsoft.com/office/drawing/2014/main" id="{DC06797E-6885-423C-AD48-8A02AE69FC99}"/>
               </a:ext>
             </a:extLst>
           </p:cNvPr>
@@ -7440,7 +8400,7 @@
         </p:xfrm>
         <a:graphic xmlns:a="http://schemas.openxmlformats.org/drawingml/2006/main">
           <a:graphicData uri="http://schemas.openxmlformats.org/drawingml/2006/chart">
-            <c:chart xmlns:r="http://schemas.openxmlformats.org/officeDocument/2006/relationships" xmlns:c="http://schemas.openxmlformats.org/drawingml/2006/chart" r:id="R4c0d9af4579d4fc9"/>
+            <c:chart xmlns:r="http://schemas.openxmlformats.org/officeDocument/2006/relationships" xmlns:c="http://schemas.openxmlformats.org/drawingml/2006/chart" r:id="R08a01c6c0bff454b"/>
           </a:graphicData>
         </a:graphic>
       </p:graphicFrame>
@@ -7456,7 +8416,7 @@
         </p:xfrm>
         <a:graphic xmlns:a="http://schemas.openxmlformats.org/drawingml/2006/main">
           <a:graphicData uri="http://schemas.openxmlformats.org/drawingml/2006/chart">
-            <c:chart xmlns:r="http://schemas.openxmlformats.org/officeDocument/2006/relationships" xmlns:c="http://schemas.openxmlformats.org/drawingml/2006/chart" r:id="R9ce664ef8e7a4ca0"/>
+            <c:chart xmlns:r="http://schemas.openxmlformats.org/officeDocument/2006/relationships" xmlns:c="http://schemas.openxmlformats.org/drawingml/2006/chart" r:id="Rbb2479b0e9904afa"/>
           </a:graphicData>
         </a:graphic>
       </p:graphicFrame>
@@ -7465,7 +8425,7 @@
           <p:cNvPr id="8" name="">
             <a:extLst xmlns:a="http://schemas.openxmlformats.org/drawingml/2006/main">
               <a:ext uri="{FF2B5EF4-FFF2-40B4-BE49-F238E27FC236}">
-                <a16:creationId xmlns:a16="http://schemas.microsoft.com/office/drawing/2014/main" id="{BE561615-67EE-4C17-B05A-FC8786380F14}"/>
+                <a16:creationId xmlns:a16="http://schemas.microsoft.com/office/drawing/2014/main" id="{80BEF548-9FBB-497E-A5F1-903603EDA822}"/>
               </a:ext>
             </a:extLst>
           </p:cNvPr>
@@ -7512,7 +8472,7 @@
                 <a:ea typeface="Arial"/>
                 <a:cs typeface="Arial"/>
               </a:rPr>
-              <a:t>Market share = company units / market units. ASP = revenue / company units.</a:t>
+              <a:t>ASP = revenue / units for company and total market (including company).</a:t>
             </a:r>
           </a:p>
         </p:txBody>
@@ -7522,7 +8482,7 @@
           <p:cNvPr id="9" name="">
             <a:extLst xmlns:a="http://schemas.openxmlformats.org/drawingml/2006/main">
               <a:ext uri="{FF2B5EF4-FFF2-40B4-BE49-F238E27FC236}">
-                <a16:creationId xmlns:a16="http://schemas.microsoft.com/office/drawing/2014/main" id="{889518F0-8BA5-440B-8F04-773B85CC5CB1}"/>
+                <a16:creationId xmlns:a16="http://schemas.microsoft.com/office/drawing/2014/main" id="{0BBAFAD9-A058-461C-8856-39C05A9BE972}"/>
               </a:ext>
             </a:extLst>
           </p:cNvPr>
@@ -7579,7 +8539,7 @@
           <p:cNvPr id="10" name="">
             <a:extLst xmlns:a="http://schemas.openxmlformats.org/drawingml/2006/main">
               <a:ext uri="{FF2B5EF4-FFF2-40B4-BE49-F238E27FC236}">
-                <a16:creationId xmlns:a16="http://schemas.microsoft.com/office/drawing/2014/main" id="{1B063F4C-ED5B-494B-A578-D23295232A2C}"/>
+                <a16:creationId xmlns:a16="http://schemas.microsoft.com/office/drawing/2014/main" id="{5302DB40-427C-4332-942A-87A8C7C065F3}"/>
               </a:ext>
             </a:extLst>
           </p:cNvPr>
@@ -7634,7 +8594,7 @@
     </p:spTree>
     <p:extLst>
       <p:ext uri="{BB962C8B-B14F-4D97-AF65-F5344CB8AC3E}">
-        <p14:creationId xmlns:p14="http://schemas.microsoft.com/office/powerpoint/2010/main" val="1213087913"/>
+        <p14:creationId xmlns:p14="http://schemas.microsoft.com/office/powerpoint/2010/main" val="2097235938"/>
       </p:ext>
     </p:extLst>
   </p:cSld>
@@ -7665,7 +8625,7 @@
           <p:cNvPr id="11" name="">
             <a:extLst xmlns:a="http://schemas.openxmlformats.org/drawingml/2006/main">
               <a:ext uri="{FF2B5EF4-FFF2-40B4-BE49-F238E27FC236}">
-                <a16:creationId xmlns:a16="http://schemas.microsoft.com/office/drawing/2014/main" id="{695E8DFA-DE60-483A-8535-3EED87D29D84}"/>
+                <a16:creationId xmlns:a16="http://schemas.microsoft.com/office/drawing/2014/main" id="{C5441E85-8136-458A-82EB-02F4D40198DC}"/>
               </a:ext>
             </a:extLst>
           </p:cNvPr>
@@ -7722,7 +8682,7 @@
           <p:cNvPr id="2" name="">
             <a:extLst xmlns:a="http://schemas.openxmlformats.org/drawingml/2006/main">
               <a:ext uri="{FF2B5EF4-FFF2-40B4-BE49-F238E27FC236}">
-                <a16:creationId xmlns:a16="http://schemas.microsoft.com/office/drawing/2014/main" id="{BDA050E3-03D3-4C92-801B-3B111C8F12C6}"/>
+                <a16:creationId xmlns:a16="http://schemas.microsoft.com/office/drawing/2014/main" id="{D9E72245-314B-484F-AD4C-16C90D3B9E01}"/>
               </a:ext>
             </a:extLst>
           </p:cNvPr>
@@ -7779,7 +8739,7 @@
           <p:cNvPr id="3" name="">
             <a:extLst xmlns:a="http://schemas.openxmlformats.org/drawingml/2006/main">
               <a:ext uri="{FF2B5EF4-FFF2-40B4-BE49-F238E27FC236}">
-                <a16:creationId xmlns:a16="http://schemas.microsoft.com/office/drawing/2014/main" id="{5783EB57-4CAE-4A18-89ED-439ABE08C57A}"/>
+                <a16:creationId xmlns:a16="http://schemas.microsoft.com/office/drawing/2014/main" id="{A60E586C-31D8-4D87-BFD0-495000738C0C}"/>
               </a:ext>
             </a:extLst>
           </p:cNvPr>
@@ -7836,7 +8796,7 @@
           <p:cNvPr id="4" name="">
             <a:extLst xmlns:a="http://schemas.openxmlformats.org/drawingml/2006/main">
               <a:ext uri="{FF2B5EF4-FFF2-40B4-BE49-F238E27FC236}">
-                <a16:creationId xmlns:a16="http://schemas.microsoft.com/office/drawing/2014/main" id="{4512E65D-554D-43FF-AF4C-60D8133F5885}"/>
+                <a16:creationId xmlns:a16="http://schemas.microsoft.com/office/drawing/2014/main" id="{236972BC-2F30-4992-B873-85BCF215C72B}"/>
               </a:ext>
             </a:extLst>
           </p:cNvPr>
@@ -7893,7 +8853,7 @@
           <p:cNvPr id="5" name="">
             <a:extLst xmlns:a="http://schemas.openxmlformats.org/drawingml/2006/main">
               <a:ext uri="{FF2B5EF4-FFF2-40B4-BE49-F238E27FC236}">
-                <a16:creationId xmlns:a16="http://schemas.microsoft.com/office/drawing/2014/main" id="{52047156-522E-4C0E-B203-EA998FD5A2E5}"/>
+                <a16:creationId xmlns:a16="http://schemas.microsoft.com/office/drawing/2014/main" id="{085B0C0A-8763-4D4C-87E2-F24576F07485}"/>
               </a:ext>
             </a:extLst>
           </p:cNvPr>
@@ -7957,7 +8917,7 @@
         </p:xfrm>
         <a:graphic xmlns:a="http://schemas.openxmlformats.org/drawingml/2006/main">
           <a:graphicData uri="http://schemas.openxmlformats.org/drawingml/2006/chart">
-            <c:chart xmlns:r="http://schemas.openxmlformats.org/officeDocument/2006/relationships" xmlns:c="http://schemas.openxmlformats.org/drawingml/2006/chart" r:id="R7f3ff29ae5174d3a"/>
+            <c:chart xmlns:r="http://schemas.openxmlformats.org/officeDocument/2006/relationships" xmlns:c="http://schemas.openxmlformats.org/drawingml/2006/chart" r:id="Re337527c46684ce1"/>
           </a:graphicData>
         </a:graphic>
       </p:graphicFrame>
@@ -7973,7 +8933,7 @@
         </p:xfrm>
         <a:graphic xmlns:a="http://schemas.openxmlformats.org/drawingml/2006/main">
           <a:graphicData uri="http://schemas.openxmlformats.org/drawingml/2006/chart">
-            <c:chart xmlns:r="http://schemas.openxmlformats.org/officeDocument/2006/relationships" xmlns:c="http://schemas.openxmlformats.org/drawingml/2006/chart" r:id="R23402bd34788446a"/>
+            <c:chart xmlns:r="http://schemas.openxmlformats.org/officeDocument/2006/relationships" xmlns:c="http://schemas.openxmlformats.org/drawingml/2006/chart" r:id="Ra6f3514c471e4c13"/>
           </a:graphicData>
         </a:graphic>
       </p:graphicFrame>
@@ -7982,7 +8942,7 @@
           <p:cNvPr id="8" name="">
             <a:extLst xmlns:a="http://schemas.openxmlformats.org/drawingml/2006/main">
               <a:ext uri="{FF2B5EF4-FFF2-40B4-BE49-F238E27FC236}">
-                <a16:creationId xmlns:a16="http://schemas.microsoft.com/office/drawing/2014/main" id="{1FBCF371-061F-472E-8EE3-6B780BD08DE9}"/>
+                <a16:creationId xmlns:a16="http://schemas.microsoft.com/office/drawing/2014/main" id="{22F8E86D-EEC3-4307-8D1B-487154142855}"/>
               </a:ext>
             </a:extLst>
           </p:cNvPr>
@@ -8029,7 +8989,7 @@
                 <a:ea typeface="Arial"/>
                 <a:cs typeface="Arial"/>
               </a:rPr>
-              <a:t>Market share = company units / market units. ASP = revenue / company units.</a:t>
+              <a:t>ASP = revenue / units for company and total market (including company).</a:t>
             </a:r>
           </a:p>
         </p:txBody>
@@ -8039,7 +8999,7 @@
           <p:cNvPr id="9" name="">
             <a:extLst xmlns:a="http://schemas.openxmlformats.org/drawingml/2006/main">
               <a:ext uri="{FF2B5EF4-FFF2-40B4-BE49-F238E27FC236}">
-                <a16:creationId xmlns:a16="http://schemas.microsoft.com/office/drawing/2014/main" id="{CC7DBE44-909E-42A5-A1DB-584C47D51419}"/>
+                <a16:creationId xmlns:a16="http://schemas.microsoft.com/office/drawing/2014/main" id="{8F421DD4-9F18-40AB-9162-0C91A98EA045}"/>
               </a:ext>
             </a:extLst>
           </p:cNvPr>
@@ -8096,7 +9056,7 @@
           <p:cNvPr id="10" name="">
             <a:extLst xmlns:a="http://schemas.openxmlformats.org/drawingml/2006/main">
               <a:ext uri="{FF2B5EF4-FFF2-40B4-BE49-F238E27FC236}">
-                <a16:creationId xmlns:a16="http://schemas.microsoft.com/office/drawing/2014/main" id="{2A016C58-DE6E-4EDC-8A23-FEED3C4979FC}"/>
+                <a16:creationId xmlns:a16="http://schemas.microsoft.com/office/drawing/2014/main" id="{6763E054-C51D-49C4-B05A-4E3D95F84042}"/>
               </a:ext>
             </a:extLst>
           </p:cNvPr>
@@ -8151,7 +9111,7 @@
     </p:spTree>
     <p:extLst>
       <p:ext uri="{BB962C8B-B14F-4D97-AF65-F5344CB8AC3E}">
-        <p14:creationId xmlns:p14="http://schemas.microsoft.com/office/powerpoint/2010/main" val="1836435204"/>
+        <p14:creationId xmlns:p14="http://schemas.microsoft.com/office/powerpoint/2010/main" val="1231231700"/>
       </p:ext>
     </p:extLst>
   </p:cSld>
@@ -8182,7 +9142,7 @@
           <p:cNvPr id="11" name="">
             <a:extLst xmlns:a="http://schemas.openxmlformats.org/drawingml/2006/main">
               <a:ext uri="{FF2B5EF4-FFF2-40B4-BE49-F238E27FC236}">
-                <a16:creationId xmlns:a16="http://schemas.microsoft.com/office/drawing/2014/main" id="{D13F0C38-A8FC-4625-BC2C-A380D5FA9976}"/>
+                <a16:creationId xmlns:a16="http://schemas.microsoft.com/office/drawing/2014/main" id="{923EB955-F0B2-49DF-9A4E-6250CA28DAB0}"/>
               </a:ext>
             </a:extLst>
           </p:cNvPr>
@@ -8239,7 +9199,7 @@
           <p:cNvPr id="2" name="">
             <a:extLst xmlns:a="http://schemas.openxmlformats.org/drawingml/2006/main">
               <a:ext uri="{FF2B5EF4-FFF2-40B4-BE49-F238E27FC236}">
-                <a16:creationId xmlns:a16="http://schemas.microsoft.com/office/drawing/2014/main" id="{70C31061-8AEF-4C73-B25D-8DF5CF9935CF}"/>
+                <a16:creationId xmlns:a16="http://schemas.microsoft.com/office/drawing/2014/main" id="{825FC19A-FABC-46FD-AA34-EEE088C64FC7}"/>
               </a:ext>
             </a:extLst>
           </p:cNvPr>
@@ -8296,7 +9256,7 @@
           <p:cNvPr id="3" name="">
             <a:extLst xmlns:a="http://schemas.openxmlformats.org/drawingml/2006/main">
               <a:ext uri="{FF2B5EF4-FFF2-40B4-BE49-F238E27FC236}">
-                <a16:creationId xmlns:a16="http://schemas.microsoft.com/office/drawing/2014/main" id="{BE177B0A-8DCA-450F-AE16-486E7AC018E6}"/>
+                <a16:creationId xmlns:a16="http://schemas.microsoft.com/office/drawing/2014/main" id="{AD36A52D-861D-4785-8B7A-C4F17889A698}"/>
               </a:ext>
             </a:extLst>
           </p:cNvPr>
@@ -8353,7 +9313,7 @@
           <p:cNvPr id="4" name="">
             <a:extLst xmlns:a="http://schemas.openxmlformats.org/drawingml/2006/main">
               <a:ext uri="{FF2B5EF4-FFF2-40B4-BE49-F238E27FC236}">
-                <a16:creationId xmlns:a16="http://schemas.microsoft.com/office/drawing/2014/main" id="{C9410255-04A9-449B-BC10-58A81C7E2995}"/>
+                <a16:creationId xmlns:a16="http://schemas.microsoft.com/office/drawing/2014/main" id="{5889D2B4-5F49-4C0C-802D-0DFC53CB12E8}"/>
               </a:ext>
             </a:extLst>
           </p:cNvPr>
@@ -8410,7 +9370,7 @@
           <p:cNvPr id="5" name="">
             <a:extLst xmlns:a="http://schemas.openxmlformats.org/drawingml/2006/main">
               <a:ext uri="{FF2B5EF4-FFF2-40B4-BE49-F238E27FC236}">
-                <a16:creationId xmlns:a16="http://schemas.microsoft.com/office/drawing/2014/main" id="{E50CBB9D-6903-4C71-9F8A-43DB977C4691}"/>
+                <a16:creationId xmlns:a16="http://schemas.microsoft.com/office/drawing/2014/main" id="{D6509C96-8E3B-4880-8031-869ADF1761A1}"/>
               </a:ext>
             </a:extLst>
           </p:cNvPr>
@@ -8474,7 +9434,7 @@
         </p:xfrm>
         <a:graphic xmlns:a="http://schemas.openxmlformats.org/drawingml/2006/main">
           <a:graphicData uri="http://schemas.openxmlformats.org/drawingml/2006/chart">
-            <c:chart xmlns:r="http://schemas.openxmlformats.org/officeDocument/2006/relationships" xmlns:c="http://schemas.openxmlformats.org/drawingml/2006/chart" r:id="Rdb684414c96b4e33"/>
+            <c:chart xmlns:r="http://schemas.openxmlformats.org/officeDocument/2006/relationships" xmlns:c="http://schemas.openxmlformats.org/drawingml/2006/chart" r:id="R948fcece3bc740e3"/>
           </a:graphicData>
         </a:graphic>
       </p:graphicFrame>
@@ -8490,7 +9450,7 @@
         </p:xfrm>
         <a:graphic xmlns:a="http://schemas.openxmlformats.org/drawingml/2006/main">
           <a:graphicData uri="http://schemas.openxmlformats.org/drawingml/2006/chart">
-            <c:chart xmlns:r="http://schemas.openxmlformats.org/officeDocument/2006/relationships" xmlns:c="http://schemas.openxmlformats.org/drawingml/2006/chart" r:id="R884773320fbb4de8"/>
+            <c:chart xmlns:r="http://schemas.openxmlformats.org/officeDocument/2006/relationships" xmlns:c="http://schemas.openxmlformats.org/drawingml/2006/chart" r:id="R43876b4d208a439c"/>
           </a:graphicData>
         </a:graphic>
       </p:graphicFrame>
@@ -8499,7 +9459,7 @@
           <p:cNvPr id="8" name="">
             <a:extLst xmlns:a="http://schemas.openxmlformats.org/drawingml/2006/main">
               <a:ext uri="{FF2B5EF4-FFF2-40B4-BE49-F238E27FC236}">
-                <a16:creationId xmlns:a16="http://schemas.microsoft.com/office/drawing/2014/main" id="{AC4FE193-B8CC-4FDE-BFBB-E06B1B923A8A}"/>
+                <a16:creationId xmlns:a16="http://schemas.microsoft.com/office/drawing/2014/main" id="{9EB23184-44CB-4989-8A97-D46B9F768480}"/>
               </a:ext>
             </a:extLst>
           </p:cNvPr>
@@ -8546,7 +9506,7 @@
                 <a:ea typeface="Arial"/>
                 <a:cs typeface="Arial"/>
               </a:rPr>
-              <a:t>Market share = company units / market units. ASP = revenue / company units.</a:t>
+              <a:t>ASP = revenue / units for company and total market (including company).</a:t>
             </a:r>
           </a:p>
         </p:txBody>
@@ -8556,7 +9516,7 @@
           <p:cNvPr id="9" name="">
             <a:extLst xmlns:a="http://schemas.openxmlformats.org/drawingml/2006/main">
               <a:ext uri="{FF2B5EF4-FFF2-40B4-BE49-F238E27FC236}">
-                <a16:creationId xmlns:a16="http://schemas.microsoft.com/office/drawing/2014/main" id="{D228637E-C133-49C4-A1E0-E1A06BC269C9}"/>
+                <a16:creationId xmlns:a16="http://schemas.microsoft.com/office/drawing/2014/main" id="{AAD33694-7165-4C4F-80D5-FC639647837A}"/>
               </a:ext>
             </a:extLst>
           </p:cNvPr>
@@ -8613,7 +9573,7 @@
           <p:cNvPr id="10" name="">
             <a:extLst xmlns:a="http://schemas.openxmlformats.org/drawingml/2006/main">
               <a:ext uri="{FF2B5EF4-FFF2-40B4-BE49-F238E27FC236}">
-                <a16:creationId xmlns:a16="http://schemas.microsoft.com/office/drawing/2014/main" id="{A5A5DD64-B886-43FF-A798-F8F364EC6B65}"/>
+                <a16:creationId xmlns:a16="http://schemas.microsoft.com/office/drawing/2014/main" id="{E9C2A49B-E6B7-46D8-B67C-CCE480EC73CE}"/>
               </a:ext>
             </a:extLst>
           </p:cNvPr>
@@ -8668,7 +9628,7 @@
     </p:spTree>
     <p:extLst>
       <p:ext uri="{BB962C8B-B14F-4D97-AF65-F5344CB8AC3E}">
-        <p14:creationId xmlns:p14="http://schemas.microsoft.com/office/powerpoint/2010/main" val="837024138"/>
+        <p14:creationId xmlns:p14="http://schemas.microsoft.com/office/powerpoint/2010/main" val="981194050"/>
       </p:ext>
     </p:extLst>
   </p:cSld>
@@ -8699,7 +9659,7 @@
           <p:cNvPr id="11" name="">
             <a:extLst xmlns:a="http://schemas.openxmlformats.org/drawingml/2006/main">
               <a:ext uri="{FF2B5EF4-FFF2-40B4-BE49-F238E27FC236}">
-                <a16:creationId xmlns:a16="http://schemas.microsoft.com/office/drawing/2014/main" id="{3DC5E8C3-E46F-4369-A7D6-D28EC53913ED}"/>
+                <a16:creationId xmlns:a16="http://schemas.microsoft.com/office/drawing/2014/main" id="{281629DD-47CF-4F79-9F46-1D07C4D24024}"/>
               </a:ext>
             </a:extLst>
           </p:cNvPr>
@@ -8756,7 +9716,7 @@
           <p:cNvPr id="2" name="">
             <a:extLst xmlns:a="http://schemas.openxmlformats.org/drawingml/2006/main">
               <a:ext uri="{FF2B5EF4-FFF2-40B4-BE49-F238E27FC236}">
-                <a16:creationId xmlns:a16="http://schemas.microsoft.com/office/drawing/2014/main" id="{BB975C5B-B8C2-4A7D-BA80-76B09515187B}"/>
+                <a16:creationId xmlns:a16="http://schemas.microsoft.com/office/drawing/2014/main" id="{016CAF11-2377-4BF5-923F-2D8AE7DF99B2}"/>
               </a:ext>
             </a:extLst>
           </p:cNvPr>
@@ -8813,7 +9773,7 @@
           <p:cNvPr id="3" name="">
             <a:extLst xmlns:a="http://schemas.openxmlformats.org/drawingml/2006/main">
               <a:ext uri="{FF2B5EF4-FFF2-40B4-BE49-F238E27FC236}">
-                <a16:creationId xmlns:a16="http://schemas.microsoft.com/office/drawing/2014/main" id="{40B3D4C0-9C2C-498F-8519-1F588A312DED}"/>
+                <a16:creationId xmlns:a16="http://schemas.microsoft.com/office/drawing/2014/main" id="{B06B85BF-4199-460D-B561-74E2FF38181F}"/>
               </a:ext>
             </a:extLst>
           </p:cNvPr>
@@ -8870,7 +9830,7 @@
           <p:cNvPr id="4" name="">
             <a:extLst xmlns:a="http://schemas.openxmlformats.org/drawingml/2006/main">
               <a:ext uri="{FF2B5EF4-FFF2-40B4-BE49-F238E27FC236}">
-                <a16:creationId xmlns:a16="http://schemas.microsoft.com/office/drawing/2014/main" id="{20D94DD0-7BED-4B15-8116-46F8E5FF0E80}"/>
+                <a16:creationId xmlns:a16="http://schemas.microsoft.com/office/drawing/2014/main" id="{1C6127D0-C06D-46F5-8D13-FD9802E211A2}"/>
               </a:ext>
             </a:extLst>
           </p:cNvPr>
@@ -8927,7 +9887,7 @@
           <p:cNvPr id="5" name="">
             <a:extLst xmlns:a="http://schemas.openxmlformats.org/drawingml/2006/main">
               <a:ext uri="{FF2B5EF4-FFF2-40B4-BE49-F238E27FC236}">
-                <a16:creationId xmlns:a16="http://schemas.microsoft.com/office/drawing/2014/main" id="{3976DA57-1435-4B23-92F0-97091B03827E}"/>
+                <a16:creationId xmlns:a16="http://schemas.microsoft.com/office/drawing/2014/main" id="{BED3CF2E-53D4-41E1-8394-6CA6A0E4BE6D}"/>
               </a:ext>
             </a:extLst>
           </p:cNvPr>
@@ -8991,7 +9951,7 @@
         </p:xfrm>
         <a:graphic xmlns:a="http://schemas.openxmlformats.org/drawingml/2006/main">
           <a:graphicData uri="http://schemas.openxmlformats.org/drawingml/2006/chart">
-            <c:chart xmlns:r="http://schemas.openxmlformats.org/officeDocument/2006/relationships" xmlns:c="http://schemas.openxmlformats.org/drawingml/2006/chart" r:id="R417e401f441a4167"/>
+            <c:chart xmlns:r="http://schemas.openxmlformats.org/officeDocument/2006/relationships" xmlns:c="http://schemas.openxmlformats.org/drawingml/2006/chart" r:id="R8a8a83fde63d47cc"/>
           </a:graphicData>
         </a:graphic>
       </p:graphicFrame>
@@ -9007,7 +9967,7 @@
         </p:xfrm>
         <a:graphic xmlns:a="http://schemas.openxmlformats.org/drawingml/2006/main">
           <a:graphicData uri="http://schemas.openxmlformats.org/drawingml/2006/chart">
-            <c:chart xmlns:r="http://schemas.openxmlformats.org/officeDocument/2006/relationships" xmlns:c="http://schemas.openxmlformats.org/drawingml/2006/chart" r:id="R40bd469b16ee46c4"/>
+            <c:chart xmlns:r="http://schemas.openxmlformats.org/officeDocument/2006/relationships" xmlns:c="http://schemas.openxmlformats.org/drawingml/2006/chart" r:id="R7a223c11db6543eb"/>
           </a:graphicData>
         </a:graphic>
       </p:graphicFrame>
@@ -9016,7 +9976,7 @@
           <p:cNvPr id="8" name="">
             <a:extLst xmlns:a="http://schemas.openxmlformats.org/drawingml/2006/main">
               <a:ext uri="{FF2B5EF4-FFF2-40B4-BE49-F238E27FC236}">
-                <a16:creationId xmlns:a16="http://schemas.microsoft.com/office/drawing/2014/main" id="{CF320357-0C55-4BD9-9FBA-7A5BD8E95561}"/>
+                <a16:creationId xmlns:a16="http://schemas.microsoft.com/office/drawing/2014/main" id="{1A3E19D4-2790-4BB4-832E-A3524794C3FC}"/>
               </a:ext>
             </a:extLst>
           </p:cNvPr>
@@ -9063,7 +10023,7 @@
                 <a:ea typeface="Arial"/>
                 <a:cs typeface="Arial"/>
               </a:rPr>
-              <a:t>Market share = company units / market units. ASP = revenue / company units.</a:t>
+              <a:t>ASP = revenue / units for company and total market (including company).</a:t>
             </a:r>
           </a:p>
         </p:txBody>
@@ -9073,7 +10033,7 @@
           <p:cNvPr id="9" name="">
             <a:extLst xmlns:a="http://schemas.openxmlformats.org/drawingml/2006/main">
               <a:ext uri="{FF2B5EF4-FFF2-40B4-BE49-F238E27FC236}">
-                <a16:creationId xmlns:a16="http://schemas.microsoft.com/office/drawing/2014/main" id="{B09B4A54-0C1B-466C-813B-2E3DB9EA5DCD}"/>
+                <a16:creationId xmlns:a16="http://schemas.microsoft.com/office/drawing/2014/main" id="{B47A3FAB-B8F8-47EF-B9DF-6B3392C65919}"/>
               </a:ext>
             </a:extLst>
           </p:cNvPr>
@@ -9130,7 +10090,7 @@
           <p:cNvPr id="10" name="">
             <a:extLst xmlns:a="http://schemas.openxmlformats.org/drawingml/2006/main">
               <a:ext uri="{FF2B5EF4-FFF2-40B4-BE49-F238E27FC236}">
-                <a16:creationId xmlns:a16="http://schemas.microsoft.com/office/drawing/2014/main" id="{8C19A13E-5BAA-4CB0-ACF0-57B4A13ECC10}"/>
+                <a16:creationId xmlns:a16="http://schemas.microsoft.com/office/drawing/2014/main" id="{BC5C91FB-76E3-4164-A6D1-57CE76A4D66E}"/>
               </a:ext>
             </a:extLst>
           </p:cNvPr>
@@ -9185,7 +10145,7 @@
     </p:spTree>
     <p:extLst>
       <p:ext uri="{BB962C8B-B14F-4D97-AF65-F5344CB8AC3E}">
-        <p14:creationId xmlns:p14="http://schemas.microsoft.com/office/powerpoint/2010/main" val="18007328"/>
+        <p14:creationId xmlns:p14="http://schemas.microsoft.com/office/powerpoint/2010/main" val="803083707"/>
       </p:ext>
     </p:extLst>
   </p:cSld>
@@ -9216,7 +10176,7 @@
           <p:cNvPr id="11" name="">
             <a:extLst xmlns:a="http://schemas.openxmlformats.org/drawingml/2006/main">
               <a:ext uri="{FF2B5EF4-FFF2-40B4-BE49-F238E27FC236}">
-                <a16:creationId xmlns:a16="http://schemas.microsoft.com/office/drawing/2014/main" id="{C889174B-22E9-4567-8756-DF87ADABCCFE}"/>
+                <a16:creationId xmlns:a16="http://schemas.microsoft.com/office/drawing/2014/main" id="{25635003-2E29-40C1-8F8E-76EDA410AB72}"/>
               </a:ext>
             </a:extLst>
           </p:cNvPr>
@@ -9273,7 +10233,7 @@
           <p:cNvPr id="2" name="">
             <a:extLst xmlns:a="http://schemas.openxmlformats.org/drawingml/2006/main">
               <a:ext uri="{FF2B5EF4-FFF2-40B4-BE49-F238E27FC236}">
-                <a16:creationId xmlns:a16="http://schemas.microsoft.com/office/drawing/2014/main" id="{D106DC59-7C19-4058-AC85-8B7F3D9E3BDD}"/>
+                <a16:creationId xmlns:a16="http://schemas.microsoft.com/office/drawing/2014/main" id="{644D0718-7CB1-43A0-B6C3-384CCE984375}"/>
               </a:ext>
             </a:extLst>
           </p:cNvPr>
@@ -9330,7 +10290,7 @@
           <p:cNvPr id="3" name="">
             <a:extLst xmlns:a="http://schemas.openxmlformats.org/drawingml/2006/main">
               <a:ext uri="{FF2B5EF4-FFF2-40B4-BE49-F238E27FC236}">
-                <a16:creationId xmlns:a16="http://schemas.microsoft.com/office/drawing/2014/main" id="{6AA1FB38-3524-4E1F-86D1-AC5CDE2E8641}"/>
+                <a16:creationId xmlns:a16="http://schemas.microsoft.com/office/drawing/2014/main" id="{52ABE5BF-7821-45A1-8BF4-9CB9BCFB75A3}"/>
               </a:ext>
             </a:extLst>
           </p:cNvPr>
@@ -9387,7 +10347,7 @@
           <p:cNvPr id="4" name="">
             <a:extLst xmlns:a="http://schemas.openxmlformats.org/drawingml/2006/main">
               <a:ext uri="{FF2B5EF4-FFF2-40B4-BE49-F238E27FC236}">
-                <a16:creationId xmlns:a16="http://schemas.microsoft.com/office/drawing/2014/main" id="{6272698A-B5B5-4173-8260-47999576E178}"/>
+                <a16:creationId xmlns:a16="http://schemas.microsoft.com/office/drawing/2014/main" id="{355130CC-5B2C-45B2-9626-CB0AAFBF5CB5}"/>
               </a:ext>
             </a:extLst>
           </p:cNvPr>
@@ -9444,7 +10404,7 @@
           <p:cNvPr id="5" name="">
             <a:extLst xmlns:a="http://schemas.openxmlformats.org/drawingml/2006/main">
               <a:ext uri="{FF2B5EF4-FFF2-40B4-BE49-F238E27FC236}">
-                <a16:creationId xmlns:a16="http://schemas.microsoft.com/office/drawing/2014/main" id="{D834A63C-AE57-4E39-93C5-F9D5D5C83F36}"/>
+                <a16:creationId xmlns:a16="http://schemas.microsoft.com/office/drawing/2014/main" id="{91126889-86F5-4B98-9ACB-82F1C88B1E64}"/>
               </a:ext>
             </a:extLst>
           </p:cNvPr>
@@ -9508,7 +10468,7 @@
         </p:xfrm>
         <a:graphic xmlns:a="http://schemas.openxmlformats.org/drawingml/2006/main">
           <a:graphicData uri="http://schemas.openxmlformats.org/drawingml/2006/chart">
-            <c:chart xmlns:r="http://schemas.openxmlformats.org/officeDocument/2006/relationships" xmlns:c="http://schemas.openxmlformats.org/drawingml/2006/chart" r:id="Ra9744fc3368c42a0"/>
+            <c:chart xmlns:r="http://schemas.openxmlformats.org/officeDocument/2006/relationships" xmlns:c="http://schemas.openxmlformats.org/drawingml/2006/chart" r:id="R896430e95f5e4120"/>
           </a:graphicData>
         </a:graphic>
       </p:graphicFrame>
@@ -9524,7 +10484,7 @@
         </p:xfrm>
         <a:graphic xmlns:a="http://schemas.openxmlformats.org/drawingml/2006/main">
           <a:graphicData uri="http://schemas.openxmlformats.org/drawingml/2006/chart">
-            <c:chart xmlns:r="http://schemas.openxmlformats.org/officeDocument/2006/relationships" xmlns:c="http://schemas.openxmlformats.org/drawingml/2006/chart" r:id="Rff10e4b55a904959"/>
+            <c:chart xmlns:r="http://schemas.openxmlformats.org/officeDocument/2006/relationships" xmlns:c="http://schemas.openxmlformats.org/drawingml/2006/chart" r:id="R05c980b7ca8e428f"/>
           </a:graphicData>
         </a:graphic>
       </p:graphicFrame>
@@ -9533,7 +10493,7 @@
           <p:cNvPr id="8" name="">
             <a:extLst xmlns:a="http://schemas.openxmlformats.org/drawingml/2006/main">
               <a:ext uri="{FF2B5EF4-FFF2-40B4-BE49-F238E27FC236}">
-                <a16:creationId xmlns:a16="http://schemas.microsoft.com/office/drawing/2014/main" id="{5A46A587-3E84-4B62-B3C2-779B557437C4}"/>
+                <a16:creationId xmlns:a16="http://schemas.microsoft.com/office/drawing/2014/main" id="{B70A90DC-6B64-4B78-95C9-2E4FCD38C8E8}"/>
               </a:ext>
             </a:extLst>
           </p:cNvPr>
@@ -9580,7 +10540,7 @@
                 <a:ea typeface="Arial"/>
                 <a:cs typeface="Arial"/>
               </a:rPr>
-              <a:t>Market share = company units / market units. ASP = revenue / company units.</a:t>
+              <a:t>ASP = revenue / units for company and total market (including company).</a:t>
             </a:r>
           </a:p>
         </p:txBody>
@@ -9590,7 +10550,7 @@
           <p:cNvPr id="9" name="">
             <a:extLst xmlns:a="http://schemas.openxmlformats.org/drawingml/2006/main">
               <a:ext uri="{FF2B5EF4-FFF2-40B4-BE49-F238E27FC236}">
-                <a16:creationId xmlns:a16="http://schemas.microsoft.com/office/drawing/2014/main" id="{0F02F25C-93A4-470B-8F8B-E85FEA7701F8}"/>
+                <a16:creationId xmlns:a16="http://schemas.microsoft.com/office/drawing/2014/main" id="{649B6705-53C9-4A50-8ECD-CC27A5D70929}"/>
               </a:ext>
             </a:extLst>
           </p:cNvPr>
@@ -9647,7 +10607,7 @@
           <p:cNvPr id="10" name="">
             <a:extLst xmlns:a="http://schemas.openxmlformats.org/drawingml/2006/main">
               <a:ext uri="{FF2B5EF4-FFF2-40B4-BE49-F238E27FC236}">
-                <a16:creationId xmlns:a16="http://schemas.microsoft.com/office/drawing/2014/main" id="{BC55AD35-6BD6-4C58-92DF-E4797767113B}"/>
+                <a16:creationId xmlns:a16="http://schemas.microsoft.com/office/drawing/2014/main" id="{14FA379A-852A-4F99-870E-E779AAF5C8B8}"/>
               </a:ext>
             </a:extLst>
           </p:cNvPr>
@@ -9702,7 +10662,7 @@
     </p:spTree>
     <p:extLst>
       <p:ext uri="{BB962C8B-B14F-4D97-AF65-F5344CB8AC3E}">
-        <p14:creationId xmlns:p14="http://schemas.microsoft.com/office/powerpoint/2010/main" val="287358275"/>
+        <p14:creationId xmlns:p14="http://schemas.microsoft.com/office/powerpoint/2010/main" val="947472475"/>
       </p:ext>
     </p:extLst>
   </p:cSld>
@@ -9733,7 +10693,7 @@
           <p:cNvPr id="11" name="">
             <a:extLst xmlns:a="http://schemas.openxmlformats.org/drawingml/2006/main">
               <a:ext uri="{FF2B5EF4-FFF2-40B4-BE49-F238E27FC236}">
-                <a16:creationId xmlns:a16="http://schemas.microsoft.com/office/drawing/2014/main" id="{EDC31773-075B-4A8C-B898-A61F19586AEE}"/>
+                <a16:creationId xmlns:a16="http://schemas.microsoft.com/office/drawing/2014/main" id="{CA501E30-AC0F-4FC0-9D13-A34A4058F080}"/>
               </a:ext>
             </a:extLst>
           </p:cNvPr>
@@ -9790,7 +10750,7 @@
           <p:cNvPr id="2" name="">
             <a:extLst xmlns:a="http://schemas.openxmlformats.org/drawingml/2006/main">
               <a:ext uri="{FF2B5EF4-FFF2-40B4-BE49-F238E27FC236}">
-                <a16:creationId xmlns:a16="http://schemas.microsoft.com/office/drawing/2014/main" id="{A6CA438C-5EF2-456A-BD14-86ADE0E45EB3}"/>
+                <a16:creationId xmlns:a16="http://schemas.microsoft.com/office/drawing/2014/main" id="{45A59D15-8921-44B3-A859-6243C3D65AA4}"/>
               </a:ext>
             </a:extLst>
           </p:cNvPr>
@@ -9847,7 +10807,7 @@
           <p:cNvPr id="3" name="">
             <a:extLst xmlns:a="http://schemas.openxmlformats.org/drawingml/2006/main">
               <a:ext uri="{FF2B5EF4-FFF2-40B4-BE49-F238E27FC236}">
-                <a16:creationId xmlns:a16="http://schemas.microsoft.com/office/drawing/2014/main" id="{F44FD404-273F-45F4-90C5-7E56E0A58337}"/>
+                <a16:creationId xmlns:a16="http://schemas.microsoft.com/office/drawing/2014/main" id="{C1D8A66C-E67B-4D9F-8AC4-7F1489BB6DF2}"/>
               </a:ext>
             </a:extLst>
           </p:cNvPr>
@@ -9904,7 +10864,7 @@
           <p:cNvPr id="4" name="">
             <a:extLst xmlns:a="http://schemas.openxmlformats.org/drawingml/2006/main">
               <a:ext uri="{FF2B5EF4-FFF2-40B4-BE49-F238E27FC236}">
-                <a16:creationId xmlns:a16="http://schemas.microsoft.com/office/drawing/2014/main" id="{E6DB933D-9E88-4C05-B2A7-512C92818D1B}"/>
+                <a16:creationId xmlns:a16="http://schemas.microsoft.com/office/drawing/2014/main" id="{93B2CB48-9422-4A7D-9238-72EBCE4F81AE}"/>
               </a:ext>
             </a:extLst>
           </p:cNvPr>
@@ -9961,7 +10921,7 @@
           <p:cNvPr id="5" name="">
             <a:extLst xmlns:a="http://schemas.openxmlformats.org/drawingml/2006/main">
               <a:ext uri="{FF2B5EF4-FFF2-40B4-BE49-F238E27FC236}">
-                <a16:creationId xmlns:a16="http://schemas.microsoft.com/office/drawing/2014/main" id="{BF063B08-04CF-46D8-8505-E7039C2891A5}"/>
+                <a16:creationId xmlns:a16="http://schemas.microsoft.com/office/drawing/2014/main" id="{6D12B4E1-FBA0-4530-A431-DC4D4B93F433}"/>
               </a:ext>
             </a:extLst>
           </p:cNvPr>
@@ -10025,7 +10985,7 @@
         </p:xfrm>
         <a:graphic xmlns:a="http://schemas.openxmlformats.org/drawingml/2006/main">
           <a:graphicData uri="http://schemas.openxmlformats.org/drawingml/2006/chart">
-            <c:chart xmlns:r="http://schemas.openxmlformats.org/officeDocument/2006/relationships" xmlns:c="http://schemas.openxmlformats.org/drawingml/2006/chart" r:id="R05de0d09ca8948e7"/>
+            <c:chart xmlns:r="http://schemas.openxmlformats.org/officeDocument/2006/relationships" xmlns:c="http://schemas.openxmlformats.org/drawingml/2006/chart" r:id="R5c8497377a294662"/>
           </a:graphicData>
         </a:graphic>
       </p:graphicFrame>
@@ -10041,7 +11001,7 @@
         </p:xfrm>
         <a:graphic xmlns:a="http://schemas.openxmlformats.org/drawingml/2006/main">
           <a:graphicData uri="http://schemas.openxmlformats.org/drawingml/2006/chart">
-            <c:chart xmlns:r="http://schemas.openxmlformats.org/officeDocument/2006/relationships" xmlns:c="http://schemas.openxmlformats.org/drawingml/2006/chart" r:id="R85a8505561174b43"/>
+            <c:chart xmlns:r="http://schemas.openxmlformats.org/officeDocument/2006/relationships" xmlns:c="http://schemas.openxmlformats.org/drawingml/2006/chart" r:id="Rd68b21d97efb442f"/>
           </a:graphicData>
         </a:graphic>
       </p:graphicFrame>
@@ -10050,7 +11010,7 @@
           <p:cNvPr id="8" name="">
             <a:extLst xmlns:a="http://schemas.openxmlformats.org/drawingml/2006/main">
               <a:ext uri="{FF2B5EF4-FFF2-40B4-BE49-F238E27FC236}">
-                <a16:creationId xmlns:a16="http://schemas.microsoft.com/office/drawing/2014/main" id="{0D02FF1D-7A07-4364-8DD7-15A2CFFE9649}"/>
+                <a16:creationId xmlns:a16="http://schemas.microsoft.com/office/drawing/2014/main" id="{68B23B3D-FBB6-4050-9E8C-9D1B8C901887}"/>
               </a:ext>
             </a:extLst>
           </p:cNvPr>
@@ -10097,7 +11057,7 @@
                 <a:ea typeface="Arial"/>
                 <a:cs typeface="Arial"/>
               </a:rPr>
-              <a:t>Market share = company units / market units. ASP = revenue / company units.</a:t>
+              <a:t>ASP = revenue / units for company and total market (including company).</a:t>
             </a:r>
           </a:p>
         </p:txBody>
@@ -10107,7 +11067,7 @@
           <p:cNvPr id="9" name="">
             <a:extLst xmlns:a="http://schemas.openxmlformats.org/drawingml/2006/main">
               <a:ext uri="{FF2B5EF4-FFF2-40B4-BE49-F238E27FC236}">
-                <a16:creationId xmlns:a16="http://schemas.microsoft.com/office/drawing/2014/main" id="{AC674835-E8A1-48FE-98EF-5374CAFC79AC}"/>
+                <a16:creationId xmlns:a16="http://schemas.microsoft.com/office/drawing/2014/main" id="{4A1F69E5-12A3-4290-BFAB-35D4C8FE4289}"/>
               </a:ext>
             </a:extLst>
           </p:cNvPr>
@@ -10164,7 +11124,7 @@
           <p:cNvPr id="10" name="">
             <a:extLst xmlns:a="http://schemas.openxmlformats.org/drawingml/2006/main">
               <a:ext uri="{FF2B5EF4-FFF2-40B4-BE49-F238E27FC236}">
-                <a16:creationId xmlns:a16="http://schemas.microsoft.com/office/drawing/2014/main" id="{5D7699EF-D37D-4290-886A-19D303D3867D}"/>
+                <a16:creationId xmlns:a16="http://schemas.microsoft.com/office/drawing/2014/main" id="{3CD8F439-7DA3-4414-96BE-5D8FA23EFA9C}"/>
               </a:ext>
             </a:extLst>
           </p:cNvPr>
@@ -10219,7 +11179,7 @@
     </p:spTree>
     <p:extLst>
       <p:ext uri="{BB962C8B-B14F-4D97-AF65-F5344CB8AC3E}">
-        <p14:creationId xmlns:p14="http://schemas.microsoft.com/office/powerpoint/2010/main" val="180778549"/>
+        <p14:creationId xmlns:p14="http://schemas.microsoft.com/office/powerpoint/2010/main" val="2028448989"/>
       </p:ext>
     </p:extLst>
   </p:cSld>
@@ -10250,7 +11210,7 @@
           <p:cNvPr id="11" name="">
             <a:extLst xmlns:a="http://schemas.openxmlformats.org/drawingml/2006/main">
               <a:ext uri="{FF2B5EF4-FFF2-40B4-BE49-F238E27FC236}">
-                <a16:creationId xmlns:a16="http://schemas.microsoft.com/office/drawing/2014/main" id="{665C8ED4-2F37-4603-A2FF-97054CA773C6}"/>
+                <a16:creationId xmlns:a16="http://schemas.microsoft.com/office/drawing/2014/main" id="{526C337A-5C9D-41DC-998D-FD29EE65FE54}"/>
               </a:ext>
             </a:extLst>
           </p:cNvPr>
@@ -10307,7 +11267,7 @@
           <p:cNvPr id="2" name="">
             <a:extLst xmlns:a="http://schemas.openxmlformats.org/drawingml/2006/main">
               <a:ext uri="{FF2B5EF4-FFF2-40B4-BE49-F238E27FC236}">
-                <a16:creationId xmlns:a16="http://schemas.microsoft.com/office/drawing/2014/main" id="{860F9477-0DE9-43F8-9497-513D2EF37817}"/>
+                <a16:creationId xmlns:a16="http://schemas.microsoft.com/office/drawing/2014/main" id="{84500D11-91E0-4776-8C67-7C2F7203FC2D}"/>
               </a:ext>
             </a:extLst>
           </p:cNvPr>
@@ -10364,7 +11324,7 @@
           <p:cNvPr id="3" name="">
             <a:extLst xmlns:a="http://schemas.openxmlformats.org/drawingml/2006/main">
               <a:ext uri="{FF2B5EF4-FFF2-40B4-BE49-F238E27FC236}">
-                <a16:creationId xmlns:a16="http://schemas.microsoft.com/office/drawing/2014/main" id="{ADE47015-610C-48E6-88D8-35CC58508E86}"/>
+                <a16:creationId xmlns:a16="http://schemas.microsoft.com/office/drawing/2014/main" id="{C46FE0BF-BC67-4718-86AE-59E90B770BB7}"/>
               </a:ext>
             </a:extLst>
           </p:cNvPr>
@@ -10421,7 +11381,7 @@
           <p:cNvPr id="4" name="">
             <a:extLst xmlns:a="http://schemas.openxmlformats.org/drawingml/2006/main">
               <a:ext uri="{FF2B5EF4-FFF2-40B4-BE49-F238E27FC236}">
-                <a16:creationId xmlns:a16="http://schemas.microsoft.com/office/drawing/2014/main" id="{C60D2CBE-F2FB-44C5-993A-6C2620CA99E3}"/>
+                <a16:creationId xmlns:a16="http://schemas.microsoft.com/office/drawing/2014/main" id="{05215DBA-452C-4F37-9D10-FB3D6C2D7342}"/>
               </a:ext>
             </a:extLst>
           </p:cNvPr>
@@ -10478,7 +11438,7 @@
           <p:cNvPr id="5" name="">
             <a:extLst xmlns:a="http://schemas.openxmlformats.org/drawingml/2006/main">
               <a:ext uri="{FF2B5EF4-FFF2-40B4-BE49-F238E27FC236}">
-                <a16:creationId xmlns:a16="http://schemas.microsoft.com/office/drawing/2014/main" id="{813165BC-7BA3-4BA6-AA2A-717E6A759146}"/>
+                <a16:creationId xmlns:a16="http://schemas.microsoft.com/office/drawing/2014/main" id="{F5FD0407-9F01-4E20-93DB-D3DCD2385842}"/>
               </a:ext>
             </a:extLst>
           </p:cNvPr>
@@ -10542,7 +11502,7 @@
         </p:xfrm>
         <a:graphic xmlns:a="http://schemas.openxmlformats.org/drawingml/2006/main">
           <a:graphicData uri="http://schemas.openxmlformats.org/drawingml/2006/chart">
-            <c:chart xmlns:r="http://schemas.openxmlformats.org/officeDocument/2006/relationships" xmlns:c="http://schemas.openxmlformats.org/drawingml/2006/chart" r:id="R77a1d97b97054e42"/>
+            <c:chart xmlns:r="http://schemas.openxmlformats.org/officeDocument/2006/relationships" xmlns:c="http://schemas.openxmlformats.org/drawingml/2006/chart" r:id="Rb6e6406c7318470a"/>
           </a:graphicData>
         </a:graphic>
       </p:graphicFrame>
@@ -10558,7 +11518,7 @@
         </p:xfrm>
         <a:graphic xmlns:a="http://schemas.openxmlformats.org/drawingml/2006/main">
           <a:graphicData uri="http://schemas.openxmlformats.org/drawingml/2006/chart">
-            <c:chart xmlns:r="http://schemas.openxmlformats.org/officeDocument/2006/relationships" xmlns:c="http://schemas.openxmlformats.org/drawingml/2006/chart" r:id="R2cbb83c8b42a424c"/>
+            <c:chart xmlns:r="http://schemas.openxmlformats.org/officeDocument/2006/relationships" xmlns:c="http://schemas.openxmlformats.org/drawingml/2006/chart" r:id="R83b7fe1a7dc44b39"/>
           </a:graphicData>
         </a:graphic>
       </p:graphicFrame>
@@ -10567,7 +11527,7 @@
           <p:cNvPr id="8" name="">
             <a:extLst xmlns:a="http://schemas.openxmlformats.org/drawingml/2006/main">
               <a:ext uri="{FF2B5EF4-FFF2-40B4-BE49-F238E27FC236}">
-                <a16:creationId xmlns:a16="http://schemas.microsoft.com/office/drawing/2014/main" id="{C784AAD6-C5A7-4654-8E7F-9C5660960A5C}"/>
+                <a16:creationId xmlns:a16="http://schemas.microsoft.com/office/drawing/2014/main" id="{AE547F18-86E2-4BD5-A9A6-9C99AF122B57}"/>
               </a:ext>
             </a:extLst>
           </p:cNvPr>
@@ -10614,7 +11574,7 @@
                 <a:ea typeface="Arial"/>
                 <a:cs typeface="Arial"/>
               </a:rPr>
-              <a:t>Market share = company units / market units. ASP = revenue / company units.</a:t>
+              <a:t>ASP = revenue / units for company and total market (including company).</a:t>
             </a:r>
           </a:p>
         </p:txBody>
@@ -10624,7 +11584,7 @@
           <p:cNvPr id="9" name="">
             <a:extLst xmlns:a="http://schemas.openxmlformats.org/drawingml/2006/main">
               <a:ext uri="{FF2B5EF4-FFF2-40B4-BE49-F238E27FC236}">
-                <a16:creationId xmlns:a16="http://schemas.microsoft.com/office/drawing/2014/main" id="{01D964F7-C6C0-4594-B3F1-82C8957F2B4E}"/>
+                <a16:creationId xmlns:a16="http://schemas.microsoft.com/office/drawing/2014/main" id="{896A380C-1D89-4B9A-B630-8DBE174844EA}"/>
               </a:ext>
             </a:extLst>
           </p:cNvPr>
@@ -10681,7 +11641,7 @@
           <p:cNvPr id="10" name="">
             <a:extLst xmlns:a="http://schemas.openxmlformats.org/drawingml/2006/main">
               <a:ext uri="{FF2B5EF4-FFF2-40B4-BE49-F238E27FC236}">
-                <a16:creationId xmlns:a16="http://schemas.microsoft.com/office/drawing/2014/main" id="{8AC7A0A7-53EB-4D9C-8F31-81F5F5785511}"/>
+                <a16:creationId xmlns:a16="http://schemas.microsoft.com/office/drawing/2014/main" id="{59FFBF75-253A-49A6-96D6-029190755E09}"/>
               </a:ext>
             </a:extLst>
           </p:cNvPr>
@@ -10736,7 +11696,7 @@
     </p:spTree>
     <p:extLst>
       <p:ext uri="{BB962C8B-B14F-4D97-AF65-F5344CB8AC3E}">
-        <p14:creationId xmlns:p14="http://schemas.microsoft.com/office/powerpoint/2010/main" val="626112125"/>
+        <p14:creationId xmlns:p14="http://schemas.microsoft.com/office/powerpoint/2010/main" val="660511951"/>
       </p:ext>
     </p:extLst>
   </p:cSld>
@@ -10767,7 +11727,7 @@
           <p:cNvPr id="11" name="">
             <a:extLst xmlns:a="http://schemas.openxmlformats.org/drawingml/2006/main">
               <a:ext uri="{FF2B5EF4-FFF2-40B4-BE49-F238E27FC236}">
-                <a16:creationId xmlns:a16="http://schemas.microsoft.com/office/drawing/2014/main" id="{96F2CC46-3C1F-46C5-8E7B-ABE55012C705}"/>
+                <a16:creationId xmlns:a16="http://schemas.microsoft.com/office/drawing/2014/main" id="{847BA9A0-6FE6-4196-8056-033FB97D9367}"/>
               </a:ext>
             </a:extLst>
           </p:cNvPr>
@@ -10824,7 +11784,7 @@
           <p:cNvPr id="2" name="">
             <a:extLst xmlns:a="http://schemas.openxmlformats.org/drawingml/2006/main">
               <a:ext uri="{FF2B5EF4-FFF2-40B4-BE49-F238E27FC236}">
-                <a16:creationId xmlns:a16="http://schemas.microsoft.com/office/drawing/2014/main" id="{96B4A474-920A-4560-AD05-4F92B99132F5}"/>
+                <a16:creationId xmlns:a16="http://schemas.microsoft.com/office/drawing/2014/main" id="{F9ED9E4D-D3A0-44E9-BF84-731D8AD7C0AE}"/>
               </a:ext>
             </a:extLst>
           </p:cNvPr>
@@ -10881,7 +11841,7 @@
           <p:cNvPr id="3" name="">
             <a:extLst xmlns:a="http://schemas.openxmlformats.org/drawingml/2006/main">
               <a:ext uri="{FF2B5EF4-FFF2-40B4-BE49-F238E27FC236}">
-                <a16:creationId xmlns:a16="http://schemas.microsoft.com/office/drawing/2014/main" id="{4BCC562F-1434-423C-8AA1-731D03B059C2}"/>
+                <a16:creationId xmlns:a16="http://schemas.microsoft.com/office/drawing/2014/main" id="{A76CB644-F7BA-464A-8EF5-B07E14F706AE}"/>
               </a:ext>
             </a:extLst>
           </p:cNvPr>
@@ -10938,7 +11898,7 @@
           <p:cNvPr id="4" name="">
             <a:extLst xmlns:a="http://schemas.openxmlformats.org/drawingml/2006/main">
               <a:ext uri="{FF2B5EF4-FFF2-40B4-BE49-F238E27FC236}">
-                <a16:creationId xmlns:a16="http://schemas.microsoft.com/office/drawing/2014/main" id="{EC1A78DB-C6EA-4D86-975A-2EDC8541AB9E}"/>
+                <a16:creationId xmlns:a16="http://schemas.microsoft.com/office/drawing/2014/main" id="{55E69D07-64FC-4F13-A604-4262482CD396}"/>
               </a:ext>
             </a:extLst>
           </p:cNvPr>
@@ -10995,7 +11955,7 @@
           <p:cNvPr id="5" name="">
             <a:extLst xmlns:a="http://schemas.openxmlformats.org/drawingml/2006/main">
               <a:ext uri="{FF2B5EF4-FFF2-40B4-BE49-F238E27FC236}">
-                <a16:creationId xmlns:a16="http://schemas.microsoft.com/office/drawing/2014/main" id="{0E062E36-6C48-4589-8FE4-9293DBBC593D}"/>
+                <a16:creationId xmlns:a16="http://schemas.microsoft.com/office/drawing/2014/main" id="{3059942A-3F73-4F1B-9D7E-394BE51ABCD4}"/>
               </a:ext>
             </a:extLst>
           </p:cNvPr>
@@ -11059,7 +12019,7 @@
         </p:xfrm>
         <a:graphic xmlns:a="http://schemas.openxmlformats.org/drawingml/2006/main">
           <a:graphicData uri="http://schemas.openxmlformats.org/drawingml/2006/chart">
-            <c:chart xmlns:r="http://schemas.openxmlformats.org/officeDocument/2006/relationships" xmlns:c="http://schemas.openxmlformats.org/drawingml/2006/chart" r:id="Re056d4926c474d96"/>
+            <c:chart xmlns:r="http://schemas.openxmlformats.org/officeDocument/2006/relationships" xmlns:c="http://schemas.openxmlformats.org/drawingml/2006/chart" r:id="Reaa6bacdd5914707"/>
           </a:graphicData>
         </a:graphic>
       </p:graphicFrame>
@@ -11075,7 +12035,7 @@
         </p:xfrm>
         <a:graphic xmlns:a="http://schemas.openxmlformats.org/drawingml/2006/main">
           <a:graphicData uri="http://schemas.openxmlformats.org/drawingml/2006/chart">
-            <c:chart xmlns:r="http://schemas.openxmlformats.org/officeDocument/2006/relationships" xmlns:c="http://schemas.openxmlformats.org/drawingml/2006/chart" r:id="R7697ab83b0eb4f5f"/>
+            <c:chart xmlns:r="http://schemas.openxmlformats.org/officeDocument/2006/relationships" xmlns:c="http://schemas.openxmlformats.org/drawingml/2006/chart" r:id="R756ad7d643ea49f5"/>
           </a:graphicData>
         </a:graphic>
       </p:graphicFrame>
@@ -11084,7 +12044,7 @@
           <p:cNvPr id="8" name="">
             <a:extLst xmlns:a="http://schemas.openxmlformats.org/drawingml/2006/main">
               <a:ext uri="{FF2B5EF4-FFF2-40B4-BE49-F238E27FC236}">
-                <a16:creationId xmlns:a16="http://schemas.microsoft.com/office/drawing/2014/main" id="{C8DB4D6A-DD38-4B66-AB19-D4A4F7ED63B2}"/>
+                <a16:creationId xmlns:a16="http://schemas.microsoft.com/office/drawing/2014/main" id="{3375432F-DC65-46BE-8BB0-AB2B6EDB6F86}"/>
               </a:ext>
             </a:extLst>
           </p:cNvPr>
@@ -11131,7 +12091,7 @@
                 <a:ea typeface="Arial"/>
                 <a:cs typeface="Arial"/>
               </a:rPr>
-              <a:t>Market share = company units / market units. ASP = revenue / company units.</a:t>
+              <a:t>ASP = revenue / units for company and total market (including company).</a:t>
             </a:r>
           </a:p>
         </p:txBody>
@@ -11141,7 +12101,7 @@
           <p:cNvPr id="9" name="">
             <a:extLst xmlns:a="http://schemas.openxmlformats.org/drawingml/2006/main">
               <a:ext uri="{FF2B5EF4-FFF2-40B4-BE49-F238E27FC236}">
-                <a16:creationId xmlns:a16="http://schemas.microsoft.com/office/drawing/2014/main" id="{C24A1D37-1205-4EF2-8EF5-2EC51EE2C4E8}"/>
+                <a16:creationId xmlns:a16="http://schemas.microsoft.com/office/drawing/2014/main" id="{4B7E0B85-2BF3-46D3-AAE6-9264B9001512}"/>
               </a:ext>
             </a:extLst>
           </p:cNvPr>
@@ -11198,7 +12158,7 @@
           <p:cNvPr id="10" name="">
             <a:extLst xmlns:a="http://schemas.openxmlformats.org/drawingml/2006/main">
               <a:ext uri="{FF2B5EF4-FFF2-40B4-BE49-F238E27FC236}">
-                <a16:creationId xmlns:a16="http://schemas.microsoft.com/office/drawing/2014/main" id="{EB2AD040-F969-42F5-9E74-173D7941E10E}"/>
+                <a16:creationId xmlns:a16="http://schemas.microsoft.com/office/drawing/2014/main" id="{7C288BCF-9EE4-4B59-8680-14417345E8FB}"/>
               </a:ext>
             </a:extLst>
           </p:cNvPr>
@@ -11253,7 +12213,7 @@
     </p:spTree>
     <p:extLst>
       <p:ext uri="{BB962C8B-B14F-4D97-AF65-F5344CB8AC3E}">
-        <p14:creationId xmlns:p14="http://schemas.microsoft.com/office/powerpoint/2010/main" val="312358265"/>
+        <p14:creationId xmlns:p14="http://schemas.microsoft.com/office/powerpoint/2010/main" val="100712371"/>
       </p:ext>
     </p:extLst>
   </p:cSld>
@@ -11284,7 +12244,7 @@
           <p:cNvPr id="11" name="">
             <a:extLst xmlns:a="http://schemas.openxmlformats.org/drawingml/2006/main">
               <a:ext uri="{FF2B5EF4-FFF2-40B4-BE49-F238E27FC236}">
-                <a16:creationId xmlns:a16="http://schemas.microsoft.com/office/drawing/2014/main" id="{D496C051-3948-4CD9-9B79-C98926EDA87E}"/>
+                <a16:creationId xmlns:a16="http://schemas.microsoft.com/office/drawing/2014/main" id="{8D5AEC79-B868-4877-8775-894A02807D60}"/>
               </a:ext>
             </a:extLst>
           </p:cNvPr>
@@ -11341,7 +12301,7 @@
           <p:cNvPr id="2" name="">
             <a:extLst xmlns:a="http://schemas.openxmlformats.org/drawingml/2006/main">
               <a:ext uri="{FF2B5EF4-FFF2-40B4-BE49-F238E27FC236}">
-                <a16:creationId xmlns:a16="http://schemas.microsoft.com/office/drawing/2014/main" id="{54D45280-7143-4E9E-8C6B-15006D41A571}"/>
+                <a16:creationId xmlns:a16="http://schemas.microsoft.com/office/drawing/2014/main" id="{5FBADBF7-B1A8-4D4C-93C3-B7FE5E22B8A7}"/>
               </a:ext>
             </a:extLst>
           </p:cNvPr>
@@ -11398,7 +12358,7 @@
           <p:cNvPr id="3" name="">
             <a:extLst xmlns:a="http://schemas.openxmlformats.org/drawingml/2006/main">
               <a:ext uri="{FF2B5EF4-FFF2-40B4-BE49-F238E27FC236}">
-                <a16:creationId xmlns:a16="http://schemas.microsoft.com/office/drawing/2014/main" id="{D48955CA-B9F3-49F8-AE73-CA070BA8B702}"/>
+                <a16:creationId xmlns:a16="http://schemas.microsoft.com/office/drawing/2014/main" id="{030C9354-C381-4904-BB1C-F1C271F4B641}"/>
               </a:ext>
             </a:extLst>
           </p:cNvPr>
@@ -11455,7 +12415,7 @@
           <p:cNvPr id="4" name="">
             <a:extLst xmlns:a="http://schemas.openxmlformats.org/drawingml/2006/main">
               <a:ext uri="{FF2B5EF4-FFF2-40B4-BE49-F238E27FC236}">
-                <a16:creationId xmlns:a16="http://schemas.microsoft.com/office/drawing/2014/main" id="{8DB93E86-93E0-4194-A6C7-4CAF524018FB}"/>
+                <a16:creationId xmlns:a16="http://schemas.microsoft.com/office/drawing/2014/main" id="{B918A036-7C80-4EA2-AB26-D6797425707F}"/>
               </a:ext>
             </a:extLst>
           </p:cNvPr>
@@ -11512,7 +12472,7 @@
           <p:cNvPr id="5" name="">
             <a:extLst xmlns:a="http://schemas.openxmlformats.org/drawingml/2006/main">
               <a:ext uri="{FF2B5EF4-FFF2-40B4-BE49-F238E27FC236}">
-                <a16:creationId xmlns:a16="http://schemas.microsoft.com/office/drawing/2014/main" id="{6C3E4D03-0FCE-412A-B6D4-DD388673C529}"/>
+                <a16:creationId xmlns:a16="http://schemas.microsoft.com/office/drawing/2014/main" id="{C39F002E-FA86-461E-BAD3-98FD35E8F83A}"/>
               </a:ext>
             </a:extLst>
           </p:cNvPr>
@@ -11576,7 +12536,7 @@
         </p:xfrm>
         <a:graphic xmlns:a="http://schemas.openxmlformats.org/drawingml/2006/main">
           <a:graphicData uri="http://schemas.openxmlformats.org/drawingml/2006/chart">
-            <c:chart xmlns:r="http://schemas.openxmlformats.org/officeDocument/2006/relationships" xmlns:c="http://schemas.openxmlformats.org/drawingml/2006/chart" r:id="Rc7bf8f45a7ee45a4"/>
+            <c:chart xmlns:r="http://schemas.openxmlformats.org/officeDocument/2006/relationships" xmlns:c="http://schemas.openxmlformats.org/drawingml/2006/chart" r:id="R9b0e76fde0844665"/>
           </a:graphicData>
         </a:graphic>
       </p:graphicFrame>
@@ -11592,7 +12552,7 @@
         </p:xfrm>
         <a:graphic xmlns:a="http://schemas.openxmlformats.org/drawingml/2006/main">
           <a:graphicData uri="http://schemas.openxmlformats.org/drawingml/2006/chart">
-            <c:chart xmlns:r="http://schemas.openxmlformats.org/officeDocument/2006/relationships" xmlns:c="http://schemas.openxmlformats.org/drawingml/2006/chart" r:id="Rd9845429abf14016"/>
+            <c:chart xmlns:r="http://schemas.openxmlformats.org/officeDocument/2006/relationships" xmlns:c="http://schemas.openxmlformats.org/drawingml/2006/chart" r:id="R2a6bc398da614fcf"/>
           </a:graphicData>
         </a:graphic>
       </p:graphicFrame>
@@ -11601,7 +12561,7 @@
           <p:cNvPr id="8" name="">
             <a:extLst xmlns:a="http://schemas.openxmlformats.org/drawingml/2006/main">
               <a:ext uri="{FF2B5EF4-FFF2-40B4-BE49-F238E27FC236}">
-                <a16:creationId xmlns:a16="http://schemas.microsoft.com/office/drawing/2014/main" id="{39A3C594-86F5-4174-9C80-F833718CF517}"/>
+                <a16:creationId xmlns:a16="http://schemas.microsoft.com/office/drawing/2014/main" id="{E2089EFD-C31F-483B-AE2E-CF496EA4B194}"/>
               </a:ext>
             </a:extLst>
           </p:cNvPr>
@@ -11648,7 +12608,7 @@
                 <a:ea typeface="Arial"/>
                 <a:cs typeface="Arial"/>
               </a:rPr>
-              <a:t>Market share = company units / market units. ASP = revenue / company units.</a:t>
+              <a:t>ASP = revenue / units for company and total market (including company).</a:t>
             </a:r>
           </a:p>
         </p:txBody>
@@ -11658,7 +12618,7 @@
           <p:cNvPr id="9" name="">
             <a:extLst xmlns:a="http://schemas.openxmlformats.org/drawingml/2006/main">
               <a:ext uri="{FF2B5EF4-FFF2-40B4-BE49-F238E27FC236}">
-                <a16:creationId xmlns:a16="http://schemas.microsoft.com/office/drawing/2014/main" id="{86D7F3FD-7480-4CB0-B05F-7D39029DD286}"/>
+                <a16:creationId xmlns:a16="http://schemas.microsoft.com/office/drawing/2014/main" id="{6EBF0799-0812-4FFC-A295-1F37D6454DF9}"/>
               </a:ext>
             </a:extLst>
           </p:cNvPr>
@@ -11715,7 +12675,7 @@
           <p:cNvPr id="10" name="">
             <a:extLst xmlns:a="http://schemas.openxmlformats.org/drawingml/2006/main">
               <a:ext uri="{FF2B5EF4-FFF2-40B4-BE49-F238E27FC236}">
-                <a16:creationId xmlns:a16="http://schemas.microsoft.com/office/drawing/2014/main" id="{4A9AECAF-B301-4F75-8B7F-E30EE369D3ED}"/>
+                <a16:creationId xmlns:a16="http://schemas.microsoft.com/office/drawing/2014/main" id="{A87E99DE-AE44-48E2-9D9A-5C16FBA008A1}"/>
               </a:ext>
             </a:extLst>
           </p:cNvPr>
@@ -11770,7 +12730,7 @@
     </p:spTree>
     <p:extLst>
       <p:ext uri="{BB962C8B-B14F-4D97-AF65-F5344CB8AC3E}">
-        <p14:creationId xmlns:p14="http://schemas.microsoft.com/office/powerpoint/2010/main" val="365983044"/>
+        <p14:creationId xmlns:p14="http://schemas.microsoft.com/office/powerpoint/2010/main" val="1216219345"/>
       </p:ext>
     </p:extLst>
   </p:cSld>
@@ -11801,7 +12761,7 @@
           <p:cNvPr id="11" name="">
             <a:extLst xmlns:a="http://schemas.openxmlformats.org/drawingml/2006/main">
               <a:ext uri="{FF2B5EF4-FFF2-40B4-BE49-F238E27FC236}">
-                <a16:creationId xmlns:a16="http://schemas.microsoft.com/office/drawing/2014/main" id="{181849C6-4F60-4C56-9887-FFE2D1388E99}"/>
+                <a16:creationId xmlns:a16="http://schemas.microsoft.com/office/drawing/2014/main" id="{92D0CE3C-7F06-435C-A531-04B5F6BEA626}"/>
               </a:ext>
             </a:extLst>
           </p:cNvPr>
@@ -11858,7 +12818,7 @@
           <p:cNvPr id="2" name="">
             <a:extLst xmlns:a="http://schemas.openxmlformats.org/drawingml/2006/main">
               <a:ext uri="{FF2B5EF4-FFF2-40B4-BE49-F238E27FC236}">
-                <a16:creationId xmlns:a16="http://schemas.microsoft.com/office/drawing/2014/main" id="{23308A01-1437-4C11-9C36-22024B201E4C}"/>
+                <a16:creationId xmlns:a16="http://schemas.microsoft.com/office/drawing/2014/main" id="{3FC802BF-FB41-40AC-AD32-4FE8BC93B99E}"/>
               </a:ext>
             </a:extLst>
           </p:cNvPr>
@@ -11915,7 +12875,7 @@
           <p:cNvPr id="3" name="">
             <a:extLst xmlns:a="http://schemas.openxmlformats.org/drawingml/2006/main">
               <a:ext uri="{FF2B5EF4-FFF2-40B4-BE49-F238E27FC236}">
-                <a16:creationId xmlns:a16="http://schemas.microsoft.com/office/drawing/2014/main" id="{E4D1BB5A-CA8B-4246-B4B1-BC23612A8F16}"/>
+                <a16:creationId xmlns:a16="http://schemas.microsoft.com/office/drawing/2014/main" id="{FD2FB67D-0496-4D22-8DCD-01D3256AAB47}"/>
               </a:ext>
             </a:extLst>
           </p:cNvPr>
@@ -11972,7 +12932,7 @@
           <p:cNvPr id="4" name="">
             <a:extLst xmlns:a="http://schemas.openxmlformats.org/drawingml/2006/main">
               <a:ext uri="{FF2B5EF4-FFF2-40B4-BE49-F238E27FC236}">
-                <a16:creationId xmlns:a16="http://schemas.microsoft.com/office/drawing/2014/main" id="{767255ED-D1D7-4E77-8334-03D02C3C4917}"/>
+                <a16:creationId xmlns:a16="http://schemas.microsoft.com/office/drawing/2014/main" id="{96B8DC21-CDBB-44D9-A881-FE65129D5D29}"/>
               </a:ext>
             </a:extLst>
           </p:cNvPr>
@@ -12029,7 +12989,7 @@
           <p:cNvPr id="5" name="">
             <a:extLst xmlns:a="http://schemas.openxmlformats.org/drawingml/2006/main">
               <a:ext uri="{FF2B5EF4-FFF2-40B4-BE49-F238E27FC236}">
-                <a16:creationId xmlns:a16="http://schemas.microsoft.com/office/drawing/2014/main" id="{90CA49E0-9B35-4399-8D65-A2E582AC9C38}"/>
+                <a16:creationId xmlns:a16="http://schemas.microsoft.com/office/drawing/2014/main" id="{4D28A042-C3ED-47B7-9CCF-D8EC16033FD7}"/>
               </a:ext>
             </a:extLst>
           </p:cNvPr>
@@ -12093,7 +13053,7 @@
         </p:xfrm>
         <a:graphic xmlns:a="http://schemas.openxmlformats.org/drawingml/2006/main">
           <a:graphicData uri="http://schemas.openxmlformats.org/drawingml/2006/chart">
-            <c:chart xmlns:r="http://schemas.openxmlformats.org/officeDocument/2006/relationships" xmlns:c="http://schemas.openxmlformats.org/drawingml/2006/chart" r:id="Re53ca895074d4300"/>
+            <c:chart xmlns:r="http://schemas.openxmlformats.org/officeDocument/2006/relationships" xmlns:c="http://schemas.openxmlformats.org/drawingml/2006/chart" r:id="R5d0fcc97516348f8"/>
           </a:graphicData>
         </a:graphic>
       </p:graphicFrame>
@@ -12109,7 +13069,7 @@
         </p:xfrm>
         <a:graphic xmlns:a="http://schemas.openxmlformats.org/drawingml/2006/main">
           <a:graphicData uri="http://schemas.openxmlformats.org/drawingml/2006/chart">
-            <c:chart xmlns:r="http://schemas.openxmlformats.org/officeDocument/2006/relationships" xmlns:c="http://schemas.openxmlformats.org/drawingml/2006/chart" r:id="Ra9438ebb02e74f20"/>
+            <c:chart xmlns:r="http://schemas.openxmlformats.org/officeDocument/2006/relationships" xmlns:c="http://schemas.openxmlformats.org/drawingml/2006/chart" r:id="R04f0d76c283f4d88"/>
           </a:graphicData>
         </a:graphic>
       </p:graphicFrame>
@@ -12118,7 +13078,7 @@
           <p:cNvPr id="8" name="">
             <a:extLst xmlns:a="http://schemas.openxmlformats.org/drawingml/2006/main">
               <a:ext uri="{FF2B5EF4-FFF2-40B4-BE49-F238E27FC236}">
-                <a16:creationId xmlns:a16="http://schemas.microsoft.com/office/drawing/2014/main" id="{BCC3A9EB-1162-43ED-B385-1B35C8A981F0}"/>
+                <a16:creationId xmlns:a16="http://schemas.microsoft.com/office/drawing/2014/main" id="{CD88184B-7215-47ED-AA44-BA1A2879A56E}"/>
               </a:ext>
             </a:extLst>
           </p:cNvPr>
@@ -12165,7 +13125,7 @@
                 <a:ea typeface="Arial"/>
                 <a:cs typeface="Arial"/>
               </a:rPr>
-              <a:t>Market share = company units / market units. ASP = revenue / company units.</a:t>
+              <a:t>ASP = revenue / units for company and total market (including company).</a:t>
             </a:r>
           </a:p>
         </p:txBody>
@@ -12175,7 +13135,7 @@
           <p:cNvPr id="9" name="">
             <a:extLst xmlns:a="http://schemas.openxmlformats.org/drawingml/2006/main">
               <a:ext uri="{FF2B5EF4-FFF2-40B4-BE49-F238E27FC236}">
-                <a16:creationId xmlns:a16="http://schemas.microsoft.com/office/drawing/2014/main" id="{C929B8D7-FF5F-4986-BC82-067612CFE4E3}"/>
+                <a16:creationId xmlns:a16="http://schemas.microsoft.com/office/drawing/2014/main" id="{7DF3BC0D-1888-46DA-899F-96C7A1C4CAFE}"/>
               </a:ext>
             </a:extLst>
           </p:cNvPr>
@@ -12232,7 +13192,7 @@
           <p:cNvPr id="10" name="">
             <a:extLst xmlns:a="http://schemas.openxmlformats.org/drawingml/2006/main">
               <a:ext uri="{FF2B5EF4-FFF2-40B4-BE49-F238E27FC236}">
-                <a16:creationId xmlns:a16="http://schemas.microsoft.com/office/drawing/2014/main" id="{8115F647-CDA9-4FDD-8DBC-C8074A0650C2}"/>
+                <a16:creationId xmlns:a16="http://schemas.microsoft.com/office/drawing/2014/main" id="{57F1E2D4-61D7-435E-AFBF-B57559DB3355}"/>
               </a:ext>
             </a:extLst>
           </p:cNvPr>
@@ -12287,7 +13247,7 @@
     </p:spTree>
     <p:extLst>
       <p:ext uri="{BB962C8B-B14F-4D97-AF65-F5344CB8AC3E}">
-        <p14:creationId xmlns:p14="http://schemas.microsoft.com/office/powerpoint/2010/main" val="973677946"/>
+        <p14:creationId xmlns:p14="http://schemas.microsoft.com/office/powerpoint/2010/main" val="1383766327"/>
       </p:ext>
     </p:extLst>
   </p:cSld>

</xml_diff>